<commit_message>
add conSnowflake_sso.py and regarding program
</commit_message>
<xml_diff>
--- a/snowflake_downloder/snowflake_downloader_manual.pptx
+++ b/snowflake_downloder/snowflake_downloader_manual.pptx
@@ -8,10 +8,10 @@
     <p:sldMasterId id="2147483794" r:id="rId4"/>
   </p:sldMasterIdLst>
   <p:notesMasterIdLst>
-    <p:notesMasterId r:id="rId12"/>
+    <p:notesMasterId r:id="rId18"/>
   </p:notesMasterIdLst>
   <p:handoutMasterIdLst>
-    <p:handoutMasterId r:id="rId13"/>
+    <p:handoutMasterId r:id="rId19"/>
   </p:handoutMasterIdLst>
   <p:sldIdLst>
     <p:sldId id="402" r:id="rId5"/>
@@ -21,6 +21,12 @@
     <p:sldId id="414" r:id="rId9"/>
     <p:sldId id="409" r:id="rId10"/>
     <p:sldId id="411" r:id="rId11"/>
+    <p:sldId id="416" r:id="rId12"/>
+    <p:sldId id="415" r:id="rId13"/>
+    <p:sldId id="418" r:id="rId14"/>
+    <p:sldId id="419" r:id="rId15"/>
+    <p:sldId id="420" r:id="rId16"/>
+    <p:sldId id="417" r:id="rId17"/>
   </p:sldIdLst>
   <p:sldSz cx="9144000" cy="6858000" type="screen4x3"/>
   <p:notesSz cx="6858000" cy="9144000"/>
@@ -546,7 +552,7 @@
                 <a:latin typeface="Yu Gothic UI" panose="020B0500000000000000" pitchFamily="50" charset="-128"/>
                 <a:ea typeface="Yu Gothic UI" panose="020B0500000000000000" pitchFamily="50" charset="-128"/>
               </a:rPr>
-              <a:t>2025/12/21</a:t>
+              <a:t>2026/3/9</a:t>
             </a:fld>
             <a:endParaRPr kumimoji="1" lang="ja-JP" altLang="en-US" dirty="0">
               <a:latin typeface="Yu Gothic UI" panose="020B0500000000000000" pitchFamily="50" charset="-128"/>
@@ -689,7 +695,7 @@
             <a:fld id="{6FB6BB65-0D3F-4A01-8C7D-E54F3269907F}" type="datetimeFigureOut">
               <a:rPr lang="ja-JP" altLang="en-US" smtClean="0"/>
               <a:pPr/>
-              <a:t>2025/12/21</a:t>
+              <a:t>2026/3/9</a:t>
             </a:fld>
             <a:endParaRPr lang="ja-JP" altLang="en-US" dirty="0"/>
           </a:p>
@@ -42086,7 +42092,15 @@
             </a:r>
             <a:r>
               <a:rPr kumimoji="1" lang="ja-JP" altLang="en-US" sz="2000" dirty="0"/>
-              <a:t>コネクタ編</a:t>
+              <a:t>コネクタ　専用</a:t>
+            </a:r>
+            <a:r>
+              <a:rPr kumimoji="1" lang="en-US" altLang="ja-JP" sz="2000" dirty="0" err="1"/>
+              <a:t>WareHouse</a:t>
+            </a:r>
+            <a:r>
+              <a:rPr kumimoji="1" lang="ja-JP" altLang="en-US" sz="2000" dirty="0"/>
+              <a:t>編</a:t>
             </a:r>
             <a:r>
               <a:rPr kumimoji="1" lang="en-US" altLang="ja-JP" sz="2000" dirty="0"/>
@@ -42475,6 +42489,1099 @@
     <p:extLst>
       <p:ext uri="{BB962C8B-B14F-4D97-AF65-F5344CB8AC3E}">
         <p14:creationId xmlns:p14="http://schemas.microsoft.com/office/powerpoint/2010/main" val="4191470580"/>
+      </p:ext>
+    </p:extLst>
+  </p:cSld>
+  <p:clrMapOvr>
+    <a:masterClrMapping/>
+  </p:clrMapOvr>
+</p:sld>
+</file>
+
+<file path=ppt/slides/slide10.xml><?xml version="1.0" encoding="utf-8"?>
+<p:sld xmlns:a="http://schemas.openxmlformats.org/drawingml/2006/main" xmlns:r="http://schemas.openxmlformats.org/officeDocument/2006/relationships" xmlns:p="http://schemas.openxmlformats.org/presentationml/2006/main">
+  <p:cSld>
+    <p:spTree>
+      <p:nvGrpSpPr>
+        <p:cNvPr id="1" name="">
+          <a:extLst>
+            <a:ext uri="{FF2B5EF4-FFF2-40B4-BE49-F238E27FC236}">
+              <a16:creationId xmlns:a16="http://schemas.microsoft.com/office/drawing/2014/main" id="{ED3F41B9-3ED7-C650-B5ED-823101A94CFF}"/>
+            </a:ext>
+          </a:extLst>
+        </p:cNvPr>
+        <p:cNvGrpSpPr/>
+        <p:nvPr/>
+      </p:nvGrpSpPr>
+      <p:grpSpPr>
+        <a:xfrm>
+          <a:off x="0" y="0"/>
+          <a:ext cx="0" cy="0"/>
+          <a:chOff x="0" y="0"/>
+          <a:chExt cx="0" cy="0"/>
+        </a:xfrm>
+      </p:grpSpPr>
+      <p:sp>
+        <p:nvSpPr>
+          <p:cNvPr id="2" name="タイトル 1">
+            <a:extLst>
+              <a:ext uri="{FF2B5EF4-FFF2-40B4-BE49-F238E27FC236}">
+                <a16:creationId xmlns:a16="http://schemas.microsoft.com/office/drawing/2014/main" id="{3D40BDBF-7F9B-D5E5-47ED-518CEBE9E6D4}"/>
+              </a:ext>
+            </a:extLst>
+          </p:cNvPr>
+          <p:cNvSpPr>
+            <a:spLocks noGrp="1"/>
+          </p:cNvSpPr>
+          <p:nvPr>
+            <p:ph type="title"/>
+          </p:nvPr>
+        </p:nvSpPr>
+        <p:spPr/>
+        <p:txBody>
+          <a:bodyPr/>
+          <a:lstStyle/>
+          <a:p>
+            <a:r>
+              <a:rPr kumimoji="1" lang="ja-JP" altLang="en-US" dirty="0"/>
+              <a:t>２．フォルダ構成</a:t>
+            </a:r>
+          </a:p>
+        </p:txBody>
+      </p:sp>
+      <p:sp>
+        <p:nvSpPr>
+          <p:cNvPr id="3" name="フッター プレースホルダー 2">
+            <a:extLst>
+              <a:ext uri="{FF2B5EF4-FFF2-40B4-BE49-F238E27FC236}">
+                <a16:creationId xmlns:a16="http://schemas.microsoft.com/office/drawing/2014/main" id="{C5948DE3-0F07-EA0C-D88E-580A6B63078E}"/>
+              </a:ext>
+            </a:extLst>
+          </p:cNvPr>
+          <p:cNvSpPr>
+            <a:spLocks noGrp="1"/>
+          </p:cNvSpPr>
+          <p:nvPr>
+            <p:ph type="ftr" sz="quarter" idx="10"/>
+          </p:nvPr>
+        </p:nvSpPr>
+        <p:spPr/>
+        <p:txBody>
+          <a:bodyPr/>
+          <a:lstStyle/>
+          <a:p>
+            <a:r>
+              <a:rPr lang="en-US" altLang="ja-JP"/>
+              <a:t>Title / Month XX, 2020 (Please enter it from the "Insert" → "Header and Footer")</a:t>
+            </a:r>
+            <a:endParaRPr lang="en-US" dirty="0"/>
+          </a:p>
+        </p:txBody>
+      </p:sp>
+      <p:sp>
+        <p:nvSpPr>
+          <p:cNvPr id="4" name="スライド番号プレースホルダー 3">
+            <a:extLst>
+              <a:ext uri="{FF2B5EF4-FFF2-40B4-BE49-F238E27FC236}">
+                <a16:creationId xmlns:a16="http://schemas.microsoft.com/office/drawing/2014/main" id="{C910D01E-1BBC-6F91-AD18-77409F474FF7}"/>
+              </a:ext>
+            </a:extLst>
+          </p:cNvPr>
+          <p:cNvSpPr>
+            <a:spLocks noGrp="1"/>
+          </p:cNvSpPr>
+          <p:nvPr>
+            <p:ph type="sldNum" sz="quarter" idx="11"/>
+          </p:nvPr>
+        </p:nvSpPr>
+        <p:spPr/>
+        <p:txBody>
+          <a:bodyPr/>
+          <a:lstStyle/>
+          <a:p>
+            <a:fld id="{A4345066-4952-40C1-BC8B-CE2851EC3EF2}" type="slidenum">
+              <a:rPr lang="ja-JP" altLang="en-US" smtClean="0">
+                <a:solidFill>
+                  <a:schemeClr val="bg1">
+                    <a:lumMod val="65000"/>
+                  </a:schemeClr>
+                </a:solidFill>
+              </a:rPr>
+              <a:pPr/>
+              <a:t>10</a:t>
+            </a:fld>
+            <a:endParaRPr lang="en-US" altLang="ja-JP" sz="1000" dirty="0">
+              <a:solidFill>
+                <a:schemeClr val="bg1">
+                  <a:lumMod val="65000"/>
+                </a:schemeClr>
+              </a:solidFill>
+            </a:endParaRPr>
+          </a:p>
+        </p:txBody>
+      </p:sp>
+      <p:sp>
+        <p:nvSpPr>
+          <p:cNvPr id="5" name="テキスト ボックス 4">
+            <a:extLst>
+              <a:ext uri="{FF2B5EF4-FFF2-40B4-BE49-F238E27FC236}">
+                <a16:creationId xmlns:a16="http://schemas.microsoft.com/office/drawing/2014/main" id="{E06FE496-43CC-27EC-FE6B-C0C639A6C4DC}"/>
+              </a:ext>
+            </a:extLst>
+          </p:cNvPr>
+          <p:cNvSpPr txBox="1"/>
+          <p:nvPr/>
+        </p:nvSpPr>
+        <p:spPr>
+          <a:xfrm>
+            <a:off x="814192" y="989556"/>
+            <a:ext cx="8246168" cy="1754326"/>
+          </a:xfrm>
+          <a:prstGeom prst="rect">
+            <a:avLst/>
+          </a:prstGeom>
+          <a:noFill/>
+        </p:spPr>
+        <p:txBody>
+          <a:bodyPr wrap="none" rtlCol="0">
+            <a:spAutoFit/>
+          </a:bodyPr>
+          <a:lstStyle/>
+          <a:p>
+            <a:r>
+              <a:rPr kumimoji="1" lang="ja-JP" altLang="en-US" dirty="0"/>
+              <a:t>📂</a:t>
+            </a:r>
+            <a:r>
+              <a:rPr kumimoji="1" lang="en-US" altLang="ja-JP" dirty="0" err="1"/>
+              <a:t>Snowflake_downloader</a:t>
+            </a:r>
+            <a:r>
+              <a:rPr kumimoji="1" lang="en-US" altLang="ja-JP" dirty="0"/>
+              <a:t> 	- </a:t>
+            </a:r>
+            <a:r>
+              <a:rPr kumimoji="1" lang="ja-JP" altLang="en-US" dirty="0"/>
+              <a:t>📂</a:t>
+            </a:r>
+            <a:r>
+              <a:rPr kumimoji="1" lang="en-US" altLang="ja-JP" dirty="0"/>
+              <a:t>log	</a:t>
+            </a:r>
+            <a:r>
+              <a:rPr lang="en-US" altLang="ja-JP" dirty="0"/>
+              <a:t>		</a:t>
+            </a:r>
+            <a:r>
+              <a:rPr lang="ja-JP" altLang="en-US" dirty="0"/>
+              <a:t>・・・ログ出力用</a:t>
+            </a:r>
+            <a:endParaRPr kumimoji="1" lang="en-US" altLang="ja-JP" dirty="0"/>
+          </a:p>
+          <a:p>
+            <a:r>
+              <a:rPr kumimoji="1" lang="en-US" altLang="ja-JP" dirty="0"/>
+              <a:t>			-</a:t>
+            </a:r>
+            <a:r>
+              <a:rPr kumimoji="1" lang="ja-JP" altLang="en-US" dirty="0"/>
+              <a:t> 📂</a:t>
+            </a:r>
+            <a:r>
+              <a:rPr kumimoji="1" lang="en-US" altLang="ja-JP" dirty="0"/>
+              <a:t>output		</a:t>
+            </a:r>
+            <a:r>
+              <a:rPr kumimoji="1" lang="ja-JP" altLang="en-US" dirty="0"/>
+              <a:t>・・・</a:t>
+            </a:r>
+            <a:r>
+              <a:rPr kumimoji="1" lang="en-US" altLang="ja-JP" dirty="0"/>
+              <a:t>csv</a:t>
+            </a:r>
+            <a:r>
+              <a:rPr kumimoji="1" lang="ja-JP" altLang="en-US" dirty="0"/>
+              <a:t>出力用</a:t>
+            </a:r>
+            <a:endParaRPr lang="en-US" altLang="ja-JP" dirty="0"/>
+          </a:p>
+          <a:p>
+            <a:r>
+              <a:rPr kumimoji="1" lang="en-US" altLang="ja-JP" dirty="0"/>
+              <a:t>			</a:t>
+            </a:r>
+            <a:r>
+              <a:rPr lang="en-US" altLang="ja-JP" dirty="0"/>
+              <a:t>- </a:t>
+            </a:r>
+            <a:r>
+              <a:rPr lang="ja-JP" altLang="en-US" dirty="0"/>
+              <a:t>📂</a:t>
+            </a:r>
+            <a:r>
+              <a:rPr lang="en-US" altLang="ja-JP" dirty="0" err="1"/>
+              <a:t>sql</a:t>
+            </a:r>
+            <a:r>
+              <a:rPr lang="en-US" altLang="ja-JP" dirty="0"/>
+              <a:t>			</a:t>
+            </a:r>
+            <a:r>
+              <a:rPr lang="ja-JP" altLang="en-US" dirty="0"/>
+              <a:t>・・・</a:t>
+            </a:r>
+            <a:r>
+              <a:rPr lang="en-US" altLang="ja-JP" dirty="0" err="1"/>
+              <a:t>sql</a:t>
+            </a:r>
+            <a:r>
+              <a:rPr lang="ja-JP" altLang="en-US" dirty="0"/>
+              <a:t>保存用</a:t>
+            </a:r>
+            <a:endParaRPr lang="en-US" altLang="ja-JP" dirty="0"/>
+          </a:p>
+          <a:p>
+            <a:r>
+              <a:rPr lang="en-US" altLang="ja-JP" dirty="0"/>
+              <a:t>			- </a:t>
+            </a:r>
+            <a:r>
+              <a:rPr lang="ja-JP" altLang="en-US" dirty="0"/>
+              <a:t>📄</a:t>
+            </a:r>
+            <a:r>
+              <a:rPr lang="en-US" altLang="ja-JP" dirty="0" err="1"/>
+              <a:t>connections.toml</a:t>
+            </a:r>
+            <a:r>
+              <a:rPr lang="en-US" altLang="ja-JP" dirty="0"/>
+              <a:t>	</a:t>
+            </a:r>
+            <a:r>
+              <a:rPr lang="ja-JP" altLang="en-US" dirty="0"/>
+              <a:t>・・・設定ファイル</a:t>
+            </a:r>
+            <a:endParaRPr lang="en-US" altLang="ja-JP" dirty="0"/>
+          </a:p>
+          <a:p>
+            <a:r>
+              <a:rPr lang="en-US" altLang="ja-JP" dirty="0"/>
+              <a:t>			- </a:t>
+            </a:r>
+            <a:r>
+              <a:rPr lang="ja-JP" altLang="en-US" dirty="0"/>
+              <a:t>📜</a:t>
+            </a:r>
+            <a:r>
+              <a:rPr lang="en-US" altLang="ja-JP" dirty="0"/>
+              <a:t>conSnowflake_sso.py	</a:t>
+            </a:r>
+            <a:r>
+              <a:rPr lang="ja-JP" altLang="en-US" dirty="0"/>
+              <a:t>・・・実行</a:t>
+            </a:r>
+            <a:r>
+              <a:rPr lang="en-US" altLang="ja-JP" dirty="0" err="1"/>
+              <a:t>prg</a:t>
+            </a:r>
+            <a:r>
+              <a:rPr lang="ja-JP" altLang="en-US" dirty="0"/>
+              <a:t>本体</a:t>
+            </a:r>
+            <a:endParaRPr lang="en-US" altLang="ja-JP" dirty="0"/>
+          </a:p>
+          <a:p>
+            <a:r>
+              <a:rPr lang="en-US" altLang="ja-JP" dirty="0"/>
+              <a:t>			- </a:t>
+            </a:r>
+            <a:r>
+              <a:rPr lang="ja-JP" altLang="en-US" dirty="0"/>
+              <a:t>📜</a:t>
+            </a:r>
+            <a:r>
+              <a:rPr lang="en-US" altLang="ja-JP" dirty="0"/>
+              <a:t>browser_wrapper.py	</a:t>
+            </a:r>
+            <a:r>
+              <a:rPr lang="ja-JP" altLang="en-US" dirty="0"/>
+              <a:t>・・・認証用ブラウザ起動用</a:t>
+            </a:r>
+            <a:endParaRPr lang="en-US" altLang="ja-JP" dirty="0"/>
+          </a:p>
+        </p:txBody>
+      </p:sp>
+      <p:sp>
+        <p:nvSpPr>
+          <p:cNvPr id="8" name="テキスト ボックス 7">
+            <a:extLst>
+              <a:ext uri="{FF2B5EF4-FFF2-40B4-BE49-F238E27FC236}">
+                <a16:creationId xmlns:a16="http://schemas.microsoft.com/office/drawing/2014/main" id="{DB42F2C2-5BBD-4DB5-623E-7EB1EE29878B}"/>
+              </a:ext>
+            </a:extLst>
+          </p:cNvPr>
+          <p:cNvSpPr txBox="1"/>
+          <p:nvPr/>
+        </p:nvSpPr>
+        <p:spPr>
+          <a:xfrm>
+            <a:off x="684213" y="2823457"/>
+            <a:ext cx="7741222" cy="923330"/>
+          </a:xfrm>
+          <a:prstGeom prst="rect">
+            <a:avLst/>
+          </a:prstGeom>
+          <a:noFill/>
+        </p:spPr>
+        <p:txBody>
+          <a:bodyPr wrap="none" rtlCol="0">
+            <a:spAutoFit/>
+          </a:bodyPr>
+          <a:lstStyle/>
+          <a:p>
+            <a:r>
+              <a:rPr kumimoji="1" lang="ja-JP" altLang="en-US" dirty="0"/>
+              <a:t>１．事前準備で作成した、</a:t>
+            </a:r>
+            <a:r>
+              <a:rPr lang="en-US" altLang="ja-JP" dirty="0" err="1"/>
+              <a:t>t</a:t>
+            </a:r>
+            <a:r>
+              <a:rPr kumimoji="1" lang="en-US" altLang="ja-JP" dirty="0" err="1"/>
+              <a:t>oml</a:t>
+            </a:r>
+            <a:r>
+              <a:rPr kumimoji="1" lang="ja-JP" altLang="en-US" dirty="0"/>
+              <a:t>ファイルを</a:t>
+            </a:r>
+            <a:r>
+              <a:rPr lang="en-US" altLang="ja-JP" dirty="0"/>
+              <a:t>conSnowflake.py</a:t>
+            </a:r>
+            <a:r>
+              <a:rPr lang="ja-JP" altLang="en-US" dirty="0"/>
+              <a:t>と同じ階層に保存する</a:t>
+            </a:r>
+            <a:endParaRPr lang="en-US" altLang="ja-JP" dirty="0"/>
+          </a:p>
+          <a:p>
+            <a:r>
+              <a:rPr lang="ja-JP" altLang="en-US" dirty="0"/>
+              <a:t>２．事前準備で作成した、</a:t>
+            </a:r>
+            <a:r>
+              <a:rPr lang="en-US" altLang="ja-JP" dirty="0" err="1"/>
+              <a:t>sql</a:t>
+            </a:r>
+            <a:r>
+              <a:rPr lang="ja-JP" altLang="en-US" dirty="0"/>
+              <a:t>ファイルを📂</a:t>
+            </a:r>
+            <a:r>
+              <a:rPr lang="en-US" altLang="ja-JP" dirty="0" err="1"/>
+              <a:t>sql</a:t>
+            </a:r>
+            <a:r>
+              <a:rPr lang="ja-JP" altLang="en-US" dirty="0"/>
+              <a:t>に保存する</a:t>
+            </a:r>
+            <a:endParaRPr lang="en-US" altLang="ja-JP" dirty="0"/>
+          </a:p>
+          <a:p>
+            <a:endParaRPr lang="en-US" altLang="ja-JP" dirty="0"/>
+          </a:p>
+        </p:txBody>
+      </p:sp>
+    </p:spTree>
+    <p:extLst>
+      <p:ext uri="{BB962C8B-B14F-4D97-AF65-F5344CB8AC3E}">
+        <p14:creationId xmlns:p14="http://schemas.microsoft.com/office/powerpoint/2010/main" val="2230516682"/>
+      </p:ext>
+    </p:extLst>
+  </p:cSld>
+  <p:clrMapOvr>
+    <a:masterClrMapping/>
+  </p:clrMapOvr>
+</p:sld>
+</file>
+
+<file path=ppt/slides/slide11.xml><?xml version="1.0" encoding="utf-8"?>
+<p:sld xmlns:a="http://schemas.openxmlformats.org/drawingml/2006/main" xmlns:r="http://schemas.openxmlformats.org/officeDocument/2006/relationships" xmlns:p="http://schemas.openxmlformats.org/presentationml/2006/main">
+  <p:cSld>
+    <p:spTree>
+      <p:nvGrpSpPr>
+        <p:cNvPr id="1" name="">
+          <a:extLst>
+            <a:ext uri="{FF2B5EF4-FFF2-40B4-BE49-F238E27FC236}">
+              <a16:creationId xmlns:a16="http://schemas.microsoft.com/office/drawing/2014/main" id="{D3FBC5C7-3D9D-7840-2106-DEDE4902F45D}"/>
+            </a:ext>
+          </a:extLst>
+        </p:cNvPr>
+        <p:cNvGrpSpPr/>
+        <p:nvPr/>
+      </p:nvGrpSpPr>
+      <p:grpSpPr>
+        <a:xfrm>
+          <a:off x="0" y="0"/>
+          <a:ext cx="0" cy="0"/>
+          <a:chOff x="0" y="0"/>
+          <a:chExt cx="0" cy="0"/>
+        </a:xfrm>
+      </p:grpSpPr>
+      <p:sp>
+        <p:nvSpPr>
+          <p:cNvPr id="2" name="タイトル 1">
+            <a:extLst>
+              <a:ext uri="{FF2B5EF4-FFF2-40B4-BE49-F238E27FC236}">
+                <a16:creationId xmlns:a16="http://schemas.microsoft.com/office/drawing/2014/main" id="{77F5210B-192D-314C-5F83-ABEBAEC0D3A5}"/>
+              </a:ext>
+            </a:extLst>
+          </p:cNvPr>
+          <p:cNvSpPr>
+            <a:spLocks noGrp="1"/>
+          </p:cNvSpPr>
+          <p:nvPr>
+            <p:ph type="title"/>
+          </p:nvPr>
+        </p:nvSpPr>
+        <p:spPr/>
+        <p:txBody>
+          <a:bodyPr/>
+          <a:lstStyle/>
+          <a:p>
+            <a:r>
+              <a:rPr kumimoji="1" lang="ja-JP" altLang="en-US" dirty="0"/>
+              <a:t>３．実行</a:t>
+            </a:r>
+          </a:p>
+        </p:txBody>
+      </p:sp>
+      <p:sp>
+        <p:nvSpPr>
+          <p:cNvPr id="3" name="フッター プレースホルダー 2">
+            <a:extLst>
+              <a:ext uri="{FF2B5EF4-FFF2-40B4-BE49-F238E27FC236}">
+                <a16:creationId xmlns:a16="http://schemas.microsoft.com/office/drawing/2014/main" id="{761D6AF7-0CB8-7B99-8456-C5FEBBEFE667}"/>
+              </a:ext>
+            </a:extLst>
+          </p:cNvPr>
+          <p:cNvSpPr>
+            <a:spLocks noGrp="1"/>
+          </p:cNvSpPr>
+          <p:nvPr>
+            <p:ph type="ftr" sz="quarter" idx="10"/>
+          </p:nvPr>
+        </p:nvSpPr>
+        <p:spPr/>
+        <p:txBody>
+          <a:bodyPr/>
+          <a:lstStyle/>
+          <a:p>
+            <a:r>
+              <a:rPr lang="en-US" altLang="ja-JP"/>
+              <a:t>Title / Month XX, 2020 (Please enter it from the "Insert" → "Header and Footer")</a:t>
+            </a:r>
+            <a:endParaRPr lang="en-US" dirty="0"/>
+          </a:p>
+        </p:txBody>
+      </p:sp>
+      <p:sp>
+        <p:nvSpPr>
+          <p:cNvPr id="4" name="スライド番号プレースホルダー 3">
+            <a:extLst>
+              <a:ext uri="{FF2B5EF4-FFF2-40B4-BE49-F238E27FC236}">
+                <a16:creationId xmlns:a16="http://schemas.microsoft.com/office/drawing/2014/main" id="{BC057195-8F59-789A-CA6C-AB9068E7CC98}"/>
+              </a:ext>
+            </a:extLst>
+          </p:cNvPr>
+          <p:cNvSpPr>
+            <a:spLocks noGrp="1"/>
+          </p:cNvSpPr>
+          <p:nvPr>
+            <p:ph type="sldNum" sz="quarter" idx="11"/>
+          </p:nvPr>
+        </p:nvSpPr>
+        <p:spPr/>
+        <p:txBody>
+          <a:bodyPr/>
+          <a:lstStyle/>
+          <a:p>
+            <a:fld id="{A4345066-4952-40C1-BC8B-CE2851EC3EF2}" type="slidenum">
+              <a:rPr lang="ja-JP" altLang="en-US" smtClean="0">
+                <a:solidFill>
+                  <a:schemeClr val="bg1">
+                    <a:lumMod val="65000"/>
+                  </a:schemeClr>
+                </a:solidFill>
+              </a:rPr>
+              <a:pPr/>
+              <a:t>11</a:t>
+            </a:fld>
+            <a:endParaRPr lang="en-US" altLang="ja-JP" sz="1000" dirty="0">
+              <a:solidFill>
+                <a:schemeClr val="bg1">
+                  <a:lumMod val="65000"/>
+                </a:schemeClr>
+              </a:solidFill>
+            </a:endParaRPr>
+          </a:p>
+        </p:txBody>
+      </p:sp>
+      <p:sp>
+        <p:nvSpPr>
+          <p:cNvPr id="5" name="テキスト ボックス 4">
+            <a:extLst>
+              <a:ext uri="{FF2B5EF4-FFF2-40B4-BE49-F238E27FC236}">
+                <a16:creationId xmlns:a16="http://schemas.microsoft.com/office/drawing/2014/main" id="{223902BD-7C93-8439-26A1-D96CEB86CE78}"/>
+              </a:ext>
+            </a:extLst>
+          </p:cNvPr>
+          <p:cNvSpPr txBox="1"/>
+          <p:nvPr/>
+        </p:nvSpPr>
+        <p:spPr>
+          <a:xfrm>
+            <a:off x="684213" y="800100"/>
+            <a:ext cx="3778599" cy="369332"/>
+          </a:xfrm>
+          <a:prstGeom prst="rect">
+            <a:avLst/>
+          </a:prstGeom>
+          <a:noFill/>
+        </p:spPr>
+        <p:txBody>
+          <a:bodyPr wrap="none" rtlCol="0">
+            <a:spAutoFit/>
+          </a:bodyPr>
+          <a:lstStyle/>
+          <a:p>
+            <a:r>
+              <a:rPr kumimoji="1" lang="ja-JP" altLang="en-US" dirty="0"/>
+              <a:t>１．</a:t>
+            </a:r>
+            <a:r>
+              <a:rPr lang="en-US" altLang="ja-JP" dirty="0"/>
+              <a:t>conSnowflake_sso.py</a:t>
+            </a:r>
+            <a:r>
+              <a:rPr lang="ja-JP" altLang="en-US" dirty="0"/>
+              <a:t>を起動する</a:t>
+            </a:r>
+            <a:endParaRPr lang="en-US" altLang="ja-JP" dirty="0"/>
+          </a:p>
+        </p:txBody>
+      </p:sp>
+    </p:spTree>
+    <p:extLst>
+      <p:ext uri="{BB962C8B-B14F-4D97-AF65-F5344CB8AC3E}">
+        <p14:creationId xmlns:p14="http://schemas.microsoft.com/office/powerpoint/2010/main" val="4249160888"/>
+      </p:ext>
+    </p:extLst>
+  </p:cSld>
+  <p:clrMapOvr>
+    <a:masterClrMapping/>
+  </p:clrMapOvr>
+</p:sld>
+</file>
+
+<file path=ppt/slides/slide12.xml><?xml version="1.0" encoding="utf-8"?>
+<p:sld xmlns:a="http://schemas.openxmlformats.org/drawingml/2006/main" xmlns:r="http://schemas.openxmlformats.org/officeDocument/2006/relationships" xmlns:p="http://schemas.openxmlformats.org/presentationml/2006/main">
+  <p:cSld>
+    <p:spTree>
+      <p:nvGrpSpPr>
+        <p:cNvPr id="1" name="">
+          <a:extLst>
+            <a:ext uri="{FF2B5EF4-FFF2-40B4-BE49-F238E27FC236}">
+              <a16:creationId xmlns:a16="http://schemas.microsoft.com/office/drawing/2014/main" id="{6DA39616-D769-8D4E-686F-6630F9A67CD6}"/>
+            </a:ext>
+          </a:extLst>
+        </p:cNvPr>
+        <p:cNvGrpSpPr/>
+        <p:nvPr/>
+      </p:nvGrpSpPr>
+      <p:grpSpPr>
+        <a:xfrm>
+          <a:off x="0" y="0"/>
+          <a:ext cx="0" cy="0"/>
+          <a:chOff x="0" y="0"/>
+          <a:chExt cx="0" cy="0"/>
+        </a:xfrm>
+      </p:grpSpPr>
+      <p:sp>
+        <p:nvSpPr>
+          <p:cNvPr id="2" name="タイトル 1">
+            <a:extLst>
+              <a:ext uri="{FF2B5EF4-FFF2-40B4-BE49-F238E27FC236}">
+                <a16:creationId xmlns:a16="http://schemas.microsoft.com/office/drawing/2014/main" id="{948E3500-168F-1BB0-BF67-501953C334E0}"/>
+              </a:ext>
+            </a:extLst>
+          </p:cNvPr>
+          <p:cNvSpPr>
+            <a:spLocks noGrp="1"/>
+          </p:cNvSpPr>
+          <p:nvPr>
+            <p:ph type="title"/>
+          </p:nvPr>
+        </p:nvSpPr>
+        <p:spPr/>
+        <p:txBody>
+          <a:bodyPr/>
+          <a:lstStyle/>
+          <a:p>
+            <a:r>
+              <a:rPr lang="ja-JP" altLang="en-US" dirty="0"/>
+              <a:t>４</a:t>
+            </a:r>
+            <a:r>
+              <a:rPr kumimoji="1" lang="ja-JP" altLang="en-US" dirty="0"/>
+              <a:t>．実行結果</a:t>
+            </a:r>
+          </a:p>
+        </p:txBody>
+      </p:sp>
+      <p:sp>
+        <p:nvSpPr>
+          <p:cNvPr id="3" name="フッター プレースホルダー 2">
+            <a:extLst>
+              <a:ext uri="{FF2B5EF4-FFF2-40B4-BE49-F238E27FC236}">
+                <a16:creationId xmlns:a16="http://schemas.microsoft.com/office/drawing/2014/main" id="{BAB24650-FC19-8068-EBBD-68FB9A31E5EF}"/>
+              </a:ext>
+            </a:extLst>
+          </p:cNvPr>
+          <p:cNvSpPr>
+            <a:spLocks noGrp="1"/>
+          </p:cNvSpPr>
+          <p:nvPr>
+            <p:ph type="ftr" sz="quarter" idx="10"/>
+          </p:nvPr>
+        </p:nvSpPr>
+        <p:spPr/>
+        <p:txBody>
+          <a:bodyPr/>
+          <a:lstStyle/>
+          <a:p>
+            <a:r>
+              <a:rPr lang="en-US" altLang="ja-JP"/>
+              <a:t>Title / Month XX, 2020 (Please enter it from the "Insert" → "Header and Footer")</a:t>
+            </a:r>
+            <a:endParaRPr lang="en-US" dirty="0"/>
+          </a:p>
+        </p:txBody>
+      </p:sp>
+      <p:sp>
+        <p:nvSpPr>
+          <p:cNvPr id="4" name="スライド番号プレースホルダー 3">
+            <a:extLst>
+              <a:ext uri="{FF2B5EF4-FFF2-40B4-BE49-F238E27FC236}">
+                <a16:creationId xmlns:a16="http://schemas.microsoft.com/office/drawing/2014/main" id="{BA159AF7-8AF1-19F6-CE36-166ED4FCCF0E}"/>
+              </a:ext>
+            </a:extLst>
+          </p:cNvPr>
+          <p:cNvSpPr>
+            <a:spLocks noGrp="1"/>
+          </p:cNvSpPr>
+          <p:nvPr>
+            <p:ph type="sldNum" sz="quarter" idx="11"/>
+          </p:nvPr>
+        </p:nvSpPr>
+        <p:spPr/>
+        <p:txBody>
+          <a:bodyPr/>
+          <a:lstStyle/>
+          <a:p>
+            <a:fld id="{A4345066-4952-40C1-BC8B-CE2851EC3EF2}" type="slidenum">
+              <a:rPr lang="ja-JP" altLang="en-US" smtClean="0">
+                <a:solidFill>
+                  <a:schemeClr val="bg1">
+                    <a:lumMod val="65000"/>
+                  </a:schemeClr>
+                </a:solidFill>
+              </a:rPr>
+              <a:pPr/>
+              <a:t>12</a:t>
+            </a:fld>
+            <a:endParaRPr lang="en-US" altLang="ja-JP" sz="1000" dirty="0">
+              <a:solidFill>
+                <a:schemeClr val="bg1">
+                  <a:lumMod val="65000"/>
+                </a:schemeClr>
+              </a:solidFill>
+            </a:endParaRPr>
+          </a:p>
+        </p:txBody>
+      </p:sp>
+      <p:sp>
+        <p:nvSpPr>
+          <p:cNvPr id="5" name="テキスト ボックス 4">
+            <a:extLst>
+              <a:ext uri="{FF2B5EF4-FFF2-40B4-BE49-F238E27FC236}">
+                <a16:creationId xmlns:a16="http://schemas.microsoft.com/office/drawing/2014/main" id="{EEBC4EDE-8257-0F0B-3AB2-975C8435716F}"/>
+              </a:ext>
+            </a:extLst>
+          </p:cNvPr>
+          <p:cNvSpPr txBox="1"/>
+          <p:nvPr/>
+        </p:nvSpPr>
+        <p:spPr>
+          <a:xfrm>
+            <a:off x="684213" y="800100"/>
+            <a:ext cx="5283819" cy="2585323"/>
+          </a:xfrm>
+          <a:prstGeom prst="rect">
+            <a:avLst/>
+          </a:prstGeom>
+          <a:noFill/>
+        </p:spPr>
+        <p:txBody>
+          <a:bodyPr wrap="none" rtlCol="0">
+            <a:spAutoFit/>
+          </a:bodyPr>
+          <a:lstStyle/>
+          <a:p>
+            <a:r>
+              <a:rPr lang="en-US" altLang="ja-JP" b="1" u="sng" dirty="0"/>
+              <a:t>Log</a:t>
+            </a:r>
+            <a:r>
+              <a:rPr lang="ja-JP" altLang="en-US" b="1" u="sng" dirty="0"/>
+              <a:t>ファイル</a:t>
+            </a:r>
+            <a:endParaRPr lang="en-US" altLang="ja-JP" b="1" u="sng" dirty="0"/>
+          </a:p>
+          <a:p>
+            <a:endParaRPr lang="en-US" altLang="ja-JP" dirty="0"/>
+          </a:p>
+          <a:p>
+            <a:r>
+              <a:rPr lang="en-US" altLang="ja-JP" dirty="0"/>
+              <a:t>		</a:t>
+            </a:r>
+            <a:r>
+              <a:rPr lang="ja-JP" altLang="en-US" dirty="0"/>
+              <a:t>ファイル名形式：年月日</a:t>
+            </a:r>
+            <a:r>
+              <a:rPr lang="en-US" altLang="ja-JP" dirty="0"/>
+              <a:t>_</a:t>
+            </a:r>
+            <a:r>
+              <a:rPr lang="ja-JP" altLang="en-US" dirty="0"/>
+              <a:t>時間</a:t>
+            </a:r>
+            <a:r>
+              <a:rPr lang="en-US" altLang="ja-JP" dirty="0"/>
+              <a:t>.log</a:t>
+            </a:r>
+          </a:p>
+          <a:p>
+            <a:r>
+              <a:rPr lang="ja-JP" altLang="en-US" dirty="0"/>
+              <a:t>　　　　　　　　↓中身　　　　</a:t>
+            </a:r>
+            <a:endParaRPr lang="en-US" altLang="ja-JP" dirty="0"/>
+          </a:p>
+          <a:p>
+            <a:endParaRPr lang="en-US" altLang="ja-JP" dirty="0"/>
+          </a:p>
+          <a:p>
+            <a:endParaRPr lang="en-US" altLang="ja-JP" dirty="0"/>
+          </a:p>
+          <a:p>
+            <a:r>
+              <a:rPr lang="en-US" altLang="ja-JP" b="1" u="sng" dirty="0"/>
+              <a:t>Csv</a:t>
+            </a:r>
+            <a:r>
+              <a:rPr lang="ja-JP" altLang="en-US" b="1" u="sng" dirty="0"/>
+              <a:t>ファイル</a:t>
+            </a:r>
+            <a:endParaRPr lang="en-US" altLang="ja-JP" b="1" u="sng" dirty="0"/>
+          </a:p>
+          <a:p>
+            <a:endParaRPr lang="en-US" altLang="ja-JP" dirty="0"/>
+          </a:p>
+          <a:p>
+            <a:r>
+              <a:rPr lang="en-US" altLang="ja-JP" dirty="0"/>
+              <a:t>		</a:t>
+            </a:r>
+            <a:r>
+              <a:rPr lang="ja-JP" altLang="en-US" dirty="0"/>
+              <a:t>ファイル名形式：年月日</a:t>
+            </a:r>
+            <a:r>
+              <a:rPr lang="en-US" altLang="ja-JP" dirty="0"/>
+              <a:t>_</a:t>
+            </a:r>
+            <a:r>
+              <a:rPr lang="en-US" altLang="ja-JP" dirty="0" err="1"/>
+              <a:t>sql</a:t>
+            </a:r>
+            <a:r>
+              <a:rPr lang="ja-JP" altLang="en-US" dirty="0"/>
+              <a:t>名</a:t>
+            </a:r>
+            <a:r>
+              <a:rPr lang="en-US" altLang="ja-JP" dirty="0"/>
+              <a:t>.csv</a:t>
+            </a:r>
+          </a:p>
+        </p:txBody>
+      </p:sp>
+      <p:pic>
+        <p:nvPicPr>
+          <p:cNvPr id="7" name="図 6">
+            <a:extLst>
+              <a:ext uri="{FF2B5EF4-FFF2-40B4-BE49-F238E27FC236}">
+                <a16:creationId xmlns:a16="http://schemas.microsoft.com/office/drawing/2014/main" id="{90FD2AB2-6497-16D5-A984-5D271B0DD94C}"/>
+              </a:ext>
+            </a:extLst>
+          </p:cNvPr>
+          <p:cNvPicPr>
+            <a:picLocks noChangeAspect="1"/>
+          </p:cNvPicPr>
+          <p:nvPr/>
+        </p:nvPicPr>
+        <p:blipFill>
+          <a:blip r:embed="rId2"/>
+          <a:stretch>
+            <a:fillRect/>
+          </a:stretch>
+        </p:blipFill>
+        <p:spPr>
+          <a:xfrm>
+            <a:off x="1112131" y="1298972"/>
+            <a:ext cx="1144126" cy="1033848"/>
+          </a:xfrm>
+          <a:prstGeom prst="rect">
+            <a:avLst/>
+          </a:prstGeom>
+        </p:spPr>
+      </p:pic>
+      <p:pic>
+        <p:nvPicPr>
+          <p:cNvPr id="9" name="図 8">
+            <a:extLst>
+              <a:ext uri="{FF2B5EF4-FFF2-40B4-BE49-F238E27FC236}">
+                <a16:creationId xmlns:a16="http://schemas.microsoft.com/office/drawing/2014/main" id="{8D00BB70-6539-38D1-80A3-0B465E1FEF15}"/>
+              </a:ext>
+            </a:extLst>
+          </p:cNvPr>
+          <p:cNvPicPr>
+            <a:picLocks noChangeAspect="1"/>
+          </p:cNvPicPr>
+          <p:nvPr/>
+        </p:nvPicPr>
+        <p:blipFill>
+          <a:blip r:embed="rId3"/>
+          <a:stretch>
+            <a:fillRect/>
+          </a:stretch>
+        </p:blipFill>
+        <p:spPr>
+          <a:xfrm>
+            <a:off x="2394547" y="1967695"/>
+            <a:ext cx="6395983" cy="365125"/>
+          </a:xfrm>
+          <a:prstGeom prst="rect">
+            <a:avLst/>
+          </a:prstGeom>
+        </p:spPr>
+      </p:pic>
+      <p:pic>
+        <p:nvPicPr>
+          <p:cNvPr id="13" name="図 12">
+            <a:extLst>
+              <a:ext uri="{FF2B5EF4-FFF2-40B4-BE49-F238E27FC236}">
+                <a16:creationId xmlns:a16="http://schemas.microsoft.com/office/drawing/2014/main" id="{039AD49E-C596-2F4F-5419-9235D528B2CC}"/>
+              </a:ext>
+            </a:extLst>
+          </p:cNvPr>
+          <p:cNvPicPr>
+            <a:picLocks noChangeAspect="1"/>
+          </p:cNvPicPr>
+          <p:nvPr/>
+        </p:nvPicPr>
+        <p:blipFill>
+          <a:blip r:embed="rId4"/>
+          <a:stretch>
+            <a:fillRect/>
+          </a:stretch>
+        </p:blipFill>
+        <p:spPr>
+          <a:xfrm>
+            <a:off x="1112132" y="2886026"/>
+            <a:ext cx="1144126" cy="406800"/>
+          </a:xfrm>
+          <a:prstGeom prst="rect">
+            <a:avLst/>
+          </a:prstGeom>
+        </p:spPr>
+      </p:pic>
+    </p:spTree>
+    <p:extLst>
+      <p:ext uri="{BB962C8B-B14F-4D97-AF65-F5344CB8AC3E}">
+        <p14:creationId xmlns:p14="http://schemas.microsoft.com/office/powerpoint/2010/main" val="2520023563"/>
+      </p:ext>
+    </p:extLst>
+  </p:cSld>
+  <p:clrMapOvr>
+    <a:masterClrMapping/>
+  </p:clrMapOvr>
+</p:sld>
+</file>
+
+<file path=ppt/slides/slide13.xml><?xml version="1.0" encoding="utf-8"?>
+<p:sld xmlns:a="http://schemas.openxmlformats.org/drawingml/2006/main" xmlns:r="http://schemas.openxmlformats.org/officeDocument/2006/relationships" xmlns:p="http://schemas.openxmlformats.org/presentationml/2006/main">
+  <p:cSld>
+    <p:spTree>
+      <p:nvGrpSpPr>
+        <p:cNvPr id="1" name=""/>
+        <p:cNvGrpSpPr/>
+        <p:nvPr/>
+      </p:nvGrpSpPr>
+      <p:grpSpPr>
+        <a:xfrm>
+          <a:off x="0" y="0"/>
+          <a:ext cx="0" cy="0"/>
+          <a:chOff x="0" y="0"/>
+          <a:chExt cx="0" cy="0"/>
+        </a:xfrm>
+      </p:grpSpPr>
+      <p:sp>
+        <p:nvSpPr>
+          <p:cNvPr id="2" name="タイトル 1">
+            <a:extLst>
+              <a:ext uri="{FF2B5EF4-FFF2-40B4-BE49-F238E27FC236}">
+                <a16:creationId xmlns:a16="http://schemas.microsoft.com/office/drawing/2014/main" id="{4776857B-E435-D47F-DB24-C78755F6A33C}"/>
+              </a:ext>
+            </a:extLst>
+          </p:cNvPr>
+          <p:cNvSpPr>
+            <a:spLocks noGrp="1"/>
+          </p:cNvSpPr>
+          <p:nvPr>
+            <p:ph type="title"/>
+          </p:nvPr>
+        </p:nvSpPr>
+        <p:spPr/>
+        <p:txBody>
+          <a:bodyPr/>
+          <a:lstStyle/>
+          <a:p>
+            <a:r>
+              <a:rPr kumimoji="1" lang="ja-JP" altLang="en-US" dirty="0"/>
+              <a:t>接続情報の通知</a:t>
+            </a:r>
+          </a:p>
+        </p:txBody>
+      </p:sp>
+      <p:sp>
+        <p:nvSpPr>
+          <p:cNvPr id="4" name="フッター プレースホルダー 3">
+            <a:extLst>
+              <a:ext uri="{FF2B5EF4-FFF2-40B4-BE49-F238E27FC236}">
+                <a16:creationId xmlns:a16="http://schemas.microsoft.com/office/drawing/2014/main" id="{9E3F17DE-630A-20CD-6465-B45FB50E769E}"/>
+              </a:ext>
+            </a:extLst>
+          </p:cNvPr>
+          <p:cNvSpPr>
+            <a:spLocks noGrp="1"/>
+          </p:cNvSpPr>
+          <p:nvPr>
+            <p:ph type="ftr" sz="quarter" idx="18"/>
+          </p:nvPr>
+        </p:nvSpPr>
+        <p:spPr/>
+        <p:txBody>
+          <a:bodyPr/>
+          <a:lstStyle/>
+          <a:p>
+            <a:r>
+              <a:rPr lang="en-US" altLang="ja-JP"/>
+              <a:t>Title / Month XX, 2020 (Please enter it from the "Insert" → "Header and Footer")</a:t>
+            </a:r>
+            <a:endParaRPr lang="en-US" dirty="0"/>
+          </a:p>
+        </p:txBody>
+      </p:sp>
+      <p:sp>
+        <p:nvSpPr>
+          <p:cNvPr id="5" name="スライド番号プレースホルダー 4">
+            <a:extLst>
+              <a:ext uri="{FF2B5EF4-FFF2-40B4-BE49-F238E27FC236}">
+                <a16:creationId xmlns:a16="http://schemas.microsoft.com/office/drawing/2014/main" id="{9C90DE56-9005-B320-9044-46CE2F290604}"/>
+              </a:ext>
+            </a:extLst>
+          </p:cNvPr>
+          <p:cNvSpPr>
+            <a:spLocks noGrp="1"/>
+          </p:cNvSpPr>
+          <p:nvPr>
+            <p:ph type="sldNum" sz="quarter" idx="19"/>
+          </p:nvPr>
+        </p:nvSpPr>
+        <p:spPr/>
+        <p:txBody>
+          <a:bodyPr/>
+          <a:lstStyle/>
+          <a:p>
+            <a:fld id="{A4345066-4952-40C1-BC8B-CE2851EC3EF2}" type="slidenum">
+              <a:rPr lang="ja-JP" altLang="en-US" smtClean="0">
+                <a:solidFill>
+                  <a:schemeClr val="bg1">
+                    <a:lumMod val="65000"/>
+                  </a:schemeClr>
+                </a:solidFill>
+              </a:rPr>
+              <a:pPr/>
+              <a:t>13</a:t>
+            </a:fld>
+            <a:endParaRPr lang="en-US" altLang="ja-JP" sz="1000" dirty="0">
+              <a:solidFill>
+                <a:schemeClr val="bg1">
+                  <a:lumMod val="65000"/>
+                </a:schemeClr>
+              </a:solidFill>
+            </a:endParaRPr>
+          </a:p>
+        </p:txBody>
+      </p:sp>
+      <p:pic>
+        <p:nvPicPr>
+          <p:cNvPr id="7" name="図 6">
+            <a:extLst>
+              <a:ext uri="{FF2B5EF4-FFF2-40B4-BE49-F238E27FC236}">
+                <a16:creationId xmlns:a16="http://schemas.microsoft.com/office/drawing/2014/main" id="{080E4862-8789-BCE2-AAD1-0BC98C0C8A0A}"/>
+              </a:ext>
+            </a:extLst>
+          </p:cNvPr>
+          <p:cNvPicPr>
+            <a:picLocks noChangeAspect="1"/>
+          </p:cNvPicPr>
+          <p:nvPr/>
+        </p:nvPicPr>
+        <p:blipFill>
+          <a:blip r:embed="rId2"/>
+          <a:stretch>
+            <a:fillRect/>
+          </a:stretch>
+        </p:blipFill>
+        <p:spPr>
+          <a:xfrm>
+            <a:off x="0" y="853567"/>
+            <a:ext cx="9144000" cy="5150866"/>
+          </a:xfrm>
+          <a:prstGeom prst="rect">
+            <a:avLst/>
+          </a:prstGeom>
+        </p:spPr>
+      </p:pic>
+    </p:spTree>
+    <p:extLst>
+      <p:ext uri="{BB962C8B-B14F-4D97-AF65-F5344CB8AC3E}">
+        <p14:creationId xmlns:p14="http://schemas.microsoft.com/office/powerpoint/2010/main" val="4002906211"/>
       </p:ext>
     </p:extLst>
   </p:cSld>
@@ -45867,6 +46974,1329 @@
     <p:extLst>
       <p:ext uri="{BB962C8B-B14F-4D97-AF65-F5344CB8AC3E}">
         <p14:creationId xmlns:p14="http://schemas.microsoft.com/office/powerpoint/2010/main" val="1547515609"/>
+      </p:ext>
+    </p:extLst>
+  </p:cSld>
+  <p:clrMapOvr>
+    <a:masterClrMapping/>
+  </p:clrMapOvr>
+</p:sld>
+</file>
+
+<file path=ppt/slides/slide8.xml><?xml version="1.0" encoding="utf-8"?>
+<p:sld xmlns:a="http://schemas.openxmlformats.org/drawingml/2006/main" xmlns:r="http://schemas.openxmlformats.org/officeDocument/2006/relationships" xmlns:p="http://schemas.openxmlformats.org/presentationml/2006/main">
+  <p:cSld>
+    <p:spTree>
+      <p:nvGrpSpPr>
+        <p:cNvPr id="1" name="">
+          <a:extLst>
+            <a:ext uri="{FF2B5EF4-FFF2-40B4-BE49-F238E27FC236}">
+              <a16:creationId xmlns:a16="http://schemas.microsoft.com/office/drawing/2014/main" id="{F4E375BF-0E86-2DBF-C8E2-08D74789B545}"/>
+            </a:ext>
+          </a:extLst>
+        </p:cNvPr>
+        <p:cNvGrpSpPr/>
+        <p:nvPr/>
+      </p:nvGrpSpPr>
+      <p:grpSpPr>
+        <a:xfrm>
+          <a:off x="0" y="0"/>
+          <a:ext cx="0" cy="0"/>
+          <a:chOff x="0" y="0"/>
+          <a:chExt cx="0" cy="0"/>
+        </a:xfrm>
+      </p:grpSpPr>
+      <p:sp>
+        <p:nvSpPr>
+          <p:cNvPr id="49" name="テキスト プレースホルダー 48">
+            <a:extLst>
+              <a:ext uri="{FF2B5EF4-FFF2-40B4-BE49-F238E27FC236}">
+                <a16:creationId xmlns:a16="http://schemas.microsoft.com/office/drawing/2014/main" id="{DE4E8152-AFAC-5CE2-E0BF-427C0328B935}"/>
+              </a:ext>
+            </a:extLst>
+          </p:cNvPr>
+          <p:cNvSpPr>
+            <a:spLocks noGrp="1"/>
+          </p:cNvSpPr>
+          <p:nvPr>
+            <p:ph type="body" sz="quarter" idx="41"/>
+          </p:nvPr>
+        </p:nvSpPr>
+        <p:spPr/>
+        <p:txBody>
+          <a:bodyPr/>
+          <a:lstStyle/>
+          <a:p>
+            <a:r>
+              <a:rPr kumimoji="1" lang="en-US" altLang="ja-JP" dirty="0"/>
+              <a:t>Snowflake</a:t>
+            </a:r>
+            <a:r>
+              <a:rPr lang="ja-JP" altLang="en-US" dirty="0"/>
+              <a:t>ダウンローダの使い方</a:t>
+            </a:r>
+            <a:endParaRPr lang="en-US" altLang="ja-JP" dirty="0"/>
+          </a:p>
+          <a:p>
+            <a:r>
+              <a:rPr kumimoji="1" lang="ja-JP" altLang="en-US" dirty="0"/>
+              <a:t>　</a:t>
+            </a:r>
+            <a:r>
+              <a:rPr kumimoji="1" lang="en-US" altLang="ja-JP" sz="2000" dirty="0"/>
+              <a:t>~python</a:t>
+            </a:r>
+            <a:r>
+              <a:rPr kumimoji="1" lang="ja-JP" altLang="en-US" sz="2000" dirty="0"/>
+              <a:t>コネクタ　</a:t>
+            </a:r>
+            <a:r>
+              <a:rPr kumimoji="1" lang="en-US" altLang="ja-JP" sz="2000" dirty="0" err="1"/>
+              <a:t>CommonWareHouse</a:t>
+            </a:r>
+            <a:r>
+              <a:rPr kumimoji="1" lang="ja-JP" altLang="en-US" sz="2000" dirty="0"/>
+              <a:t>編</a:t>
+            </a:r>
+            <a:r>
+              <a:rPr kumimoji="1" lang="en-US" altLang="ja-JP" sz="2000" dirty="0"/>
+              <a:t>~</a:t>
+            </a:r>
+            <a:endParaRPr kumimoji="1" lang="ja-JP" altLang="en-US" dirty="0"/>
+          </a:p>
+        </p:txBody>
+      </p:sp>
+      <p:sp>
+        <p:nvSpPr>
+          <p:cNvPr id="34" name="テキスト プレースホルダー 33">
+            <a:extLst>
+              <a:ext uri="{FF2B5EF4-FFF2-40B4-BE49-F238E27FC236}">
+                <a16:creationId xmlns:a16="http://schemas.microsoft.com/office/drawing/2014/main" id="{71D6CF1C-F358-9B4F-381A-18BCCF51A48C}"/>
+              </a:ext>
+            </a:extLst>
+          </p:cNvPr>
+          <p:cNvSpPr>
+            <a:spLocks noGrp="1"/>
+          </p:cNvSpPr>
+          <p:nvPr>
+            <p:ph type="body" sz="quarter" idx="11"/>
+          </p:nvPr>
+        </p:nvSpPr>
+        <p:spPr/>
+        <p:txBody>
+          <a:bodyPr/>
+          <a:lstStyle/>
+          <a:p>
+            <a:endParaRPr kumimoji="1" lang="ja-JP" altLang="en-US" dirty="0"/>
+          </a:p>
+        </p:txBody>
+      </p:sp>
+      <p:sp>
+        <p:nvSpPr>
+          <p:cNvPr id="36" name="図プレースホルダー 35">
+            <a:extLst>
+              <a:ext uri="{FF2B5EF4-FFF2-40B4-BE49-F238E27FC236}">
+                <a16:creationId xmlns:a16="http://schemas.microsoft.com/office/drawing/2014/main" id="{1EA196A4-E064-24D1-1B2D-FA0963FE6D82}"/>
+              </a:ext>
+            </a:extLst>
+          </p:cNvPr>
+          <p:cNvSpPr>
+            <a:spLocks noGrp="1"/>
+          </p:cNvSpPr>
+          <p:nvPr>
+            <p:ph type="pic" sz="quarter" idx="13"/>
+          </p:nvPr>
+        </p:nvSpPr>
+        <p:spPr/>
+        <p:txBody>
+          <a:bodyPr/>
+          <a:lstStyle/>
+          <a:p>
+            <a:endParaRPr lang="ja-JP" altLang="en-US"/>
+          </a:p>
+        </p:txBody>
+      </p:sp>
+      <p:sp>
+        <p:nvSpPr>
+          <p:cNvPr id="37" name="図プレースホルダー 36">
+            <a:extLst>
+              <a:ext uri="{FF2B5EF4-FFF2-40B4-BE49-F238E27FC236}">
+                <a16:creationId xmlns:a16="http://schemas.microsoft.com/office/drawing/2014/main" id="{366E94B9-5519-1EDD-6176-204CB71AC6C6}"/>
+              </a:ext>
+            </a:extLst>
+          </p:cNvPr>
+          <p:cNvSpPr>
+            <a:spLocks noGrp="1"/>
+          </p:cNvSpPr>
+          <p:nvPr>
+            <p:ph type="pic" sz="quarter" idx="14"/>
+          </p:nvPr>
+        </p:nvSpPr>
+        <p:spPr/>
+        <p:txBody>
+          <a:bodyPr/>
+          <a:lstStyle/>
+          <a:p>
+            <a:endParaRPr lang="ja-JP" altLang="en-US"/>
+          </a:p>
+        </p:txBody>
+      </p:sp>
+      <p:sp>
+        <p:nvSpPr>
+          <p:cNvPr id="38" name="図プレースホルダー 37">
+            <a:extLst>
+              <a:ext uri="{FF2B5EF4-FFF2-40B4-BE49-F238E27FC236}">
+                <a16:creationId xmlns:a16="http://schemas.microsoft.com/office/drawing/2014/main" id="{2D2BC42F-ABDE-A11A-AA4C-C8980DCDC2F1}"/>
+              </a:ext>
+            </a:extLst>
+          </p:cNvPr>
+          <p:cNvSpPr>
+            <a:spLocks noGrp="1"/>
+          </p:cNvSpPr>
+          <p:nvPr>
+            <p:ph type="pic" sz="quarter" idx="18"/>
+          </p:nvPr>
+        </p:nvSpPr>
+        <p:spPr/>
+        <p:txBody>
+          <a:bodyPr/>
+          <a:lstStyle/>
+          <a:p>
+            <a:endParaRPr lang="ja-JP" altLang="en-US"/>
+          </a:p>
+        </p:txBody>
+      </p:sp>
+      <p:sp>
+        <p:nvSpPr>
+          <p:cNvPr id="39" name="図プレースホルダー 38">
+            <a:extLst>
+              <a:ext uri="{FF2B5EF4-FFF2-40B4-BE49-F238E27FC236}">
+                <a16:creationId xmlns:a16="http://schemas.microsoft.com/office/drawing/2014/main" id="{24551F39-A10A-B760-CAB1-23BFFBB33642}"/>
+              </a:ext>
+            </a:extLst>
+          </p:cNvPr>
+          <p:cNvSpPr>
+            <a:spLocks noGrp="1"/>
+          </p:cNvSpPr>
+          <p:nvPr>
+            <p:ph type="pic" sz="quarter" idx="19"/>
+          </p:nvPr>
+        </p:nvSpPr>
+        <p:spPr/>
+        <p:txBody>
+          <a:bodyPr/>
+          <a:lstStyle/>
+          <a:p>
+            <a:endParaRPr lang="ja-JP" altLang="en-US"/>
+          </a:p>
+        </p:txBody>
+      </p:sp>
+      <p:sp>
+        <p:nvSpPr>
+          <p:cNvPr id="40" name="図プレースホルダー 39">
+            <a:extLst>
+              <a:ext uri="{FF2B5EF4-FFF2-40B4-BE49-F238E27FC236}">
+                <a16:creationId xmlns:a16="http://schemas.microsoft.com/office/drawing/2014/main" id="{346ACF87-79F9-E6A2-93E5-F9629415ED59}"/>
+              </a:ext>
+            </a:extLst>
+          </p:cNvPr>
+          <p:cNvSpPr>
+            <a:spLocks noGrp="1"/>
+          </p:cNvSpPr>
+          <p:nvPr>
+            <p:ph type="pic" sz="quarter" idx="23"/>
+          </p:nvPr>
+        </p:nvSpPr>
+        <p:spPr/>
+        <p:txBody>
+          <a:bodyPr/>
+          <a:lstStyle/>
+          <a:p>
+            <a:endParaRPr lang="ja-JP" altLang="en-US"/>
+          </a:p>
+        </p:txBody>
+      </p:sp>
+      <p:sp>
+        <p:nvSpPr>
+          <p:cNvPr id="41" name="図プレースホルダー 40">
+            <a:extLst>
+              <a:ext uri="{FF2B5EF4-FFF2-40B4-BE49-F238E27FC236}">
+                <a16:creationId xmlns:a16="http://schemas.microsoft.com/office/drawing/2014/main" id="{B13FC601-B29A-FB6D-AB5F-CD93BF74EC3A}"/>
+              </a:ext>
+            </a:extLst>
+          </p:cNvPr>
+          <p:cNvSpPr>
+            <a:spLocks noGrp="1"/>
+          </p:cNvSpPr>
+          <p:nvPr>
+            <p:ph type="pic" sz="quarter" idx="24"/>
+          </p:nvPr>
+        </p:nvSpPr>
+        <p:spPr/>
+        <p:txBody>
+          <a:bodyPr/>
+          <a:lstStyle/>
+          <a:p>
+            <a:endParaRPr lang="ja-JP" altLang="en-US"/>
+          </a:p>
+        </p:txBody>
+      </p:sp>
+      <p:sp>
+        <p:nvSpPr>
+          <p:cNvPr id="42" name="図プレースホルダー 41">
+            <a:extLst>
+              <a:ext uri="{FF2B5EF4-FFF2-40B4-BE49-F238E27FC236}">
+                <a16:creationId xmlns:a16="http://schemas.microsoft.com/office/drawing/2014/main" id="{D609FADB-6C6C-8643-7E22-18920EB8DEF9}"/>
+              </a:ext>
+            </a:extLst>
+          </p:cNvPr>
+          <p:cNvSpPr>
+            <a:spLocks noGrp="1"/>
+          </p:cNvSpPr>
+          <p:nvPr>
+            <p:ph type="pic" sz="quarter" idx="28"/>
+          </p:nvPr>
+        </p:nvSpPr>
+        <p:spPr/>
+        <p:txBody>
+          <a:bodyPr/>
+          <a:lstStyle/>
+          <a:p>
+            <a:endParaRPr lang="ja-JP" altLang="en-US"/>
+          </a:p>
+        </p:txBody>
+      </p:sp>
+      <p:sp>
+        <p:nvSpPr>
+          <p:cNvPr id="43" name="図プレースホルダー 42">
+            <a:extLst>
+              <a:ext uri="{FF2B5EF4-FFF2-40B4-BE49-F238E27FC236}">
+                <a16:creationId xmlns:a16="http://schemas.microsoft.com/office/drawing/2014/main" id="{CB01CF55-B691-D245-39A8-636EF30F6E7C}"/>
+              </a:ext>
+            </a:extLst>
+          </p:cNvPr>
+          <p:cNvSpPr>
+            <a:spLocks noGrp="1"/>
+          </p:cNvSpPr>
+          <p:nvPr>
+            <p:ph type="pic" sz="quarter" idx="29"/>
+          </p:nvPr>
+        </p:nvSpPr>
+        <p:spPr/>
+        <p:txBody>
+          <a:bodyPr/>
+          <a:lstStyle/>
+          <a:p>
+            <a:endParaRPr lang="ja-JP" altLang="en-US"/>
+          </a:p>
+        </p:txBody>
+      </p:sp>
+      <p:sp>
+        <p:nvSpPr>
+          <p:cNvPr id="44" name="図プレースホルダー 43">
+            <a:extLst>
+              <a:ext uri="{FF2B5EF4-FFF2-40B4-BE49-F238E27FC236}">
+                <a16:creationId xmlns:a16="http://schemas.microsoft.com/office/drawing/2014/main" id="{F4F341CB-DC12-F85C-C6DF-77D6E1DE8CBC}"/>
+              </a:ext>
+            </a:extLst>
+          </p:cNvPr>
+          <p:cNvSpPr>
+            <a:spLocks noGrp="1"/>
+          </p:cNvSpPr>
+          <p:nvPr>
+            <p:ph type="pic" sz="quarter" idx="30"/>
+          </p:nvPr>
+        </p:nvSpPr>
+        <p:spPr/>
+        <p:txBody>
+          <a:bodyPr/>
+          <a:lstStyle/>
+          <a:p>
+            <a:endParaRPr lang="ja-JP" altLang="en-US"/>
+          </a:p>
+        </p:txBody>
+      </p:sp>
+      <p:sp>
+        <p:nvSpPr>
+          <p:cNvPr id="45" name="図プレースホルダー 44">
+            <a:extLst>
+              <a:ext uri="{FF2B5EF4-FFF2-40B4-BE49-F238E27FC236}">
+                <a16:creationId xmlns:a16="http://schemas.microsoft.com/office/drawing/2014/main" id="{B25EEDC9-921B-369E-C09E-630D7B249B07}"/>
+              </a:ext>
+            </a:extLst>
+          </p:cNvPr>
+          <p:cNvSpPr>
+            <a:spLocks noGrp="1"/>
+          </p:cNvSpPr>
+          <p:nvPr>
+            <p:ph type="pic" sz="quarter" idx="33"/>
+          </p:nvPr>
+        </p:nvSpPr>
+        <p:spPr/>
+        <p:txBody>
+          <a:bodyPr/>
+          <a:lstStyle/>
+          <a:p>
+            <a:endParaRPr lang="ja-JP" altLang="en-US"/>
+          </a:p>
+        </p:txBody>
+      </p:sp>
+      <p:sp>
+        <p:nvSpPr>
+          <p:cNvPr id="46" name="図プレースホルダー 45">
+            <a:extLst>
+              <a:ext uri="{FF2B5EF4-FFF2-40B4-BE49-F238E27FC236}">
+                <a16:creationId xmlns:a16="http://schemas.microsoft.com/office/drawing/2014/main" id="{A6743085-6E35-C2AC-5290-8679E9EDB6E7}"/>
+              </a:ext>
+            </a:extLst>
+          </p:cNvPr>
+          <p:cNvSpPr>
+            <a:spLocks noGrp="1"/>
+          </p:cNvSpPr>
+          <p:nvPr>
+            <p:ph type="pic" sz="quarter" idx="34"/>
+          </p:nvPr>
+        </p:nvSpPr>
+        <p:spPr/>
+        <p:txBody>
+          <a:bodyPr/>
+          <a:lstStyle/>
+          <a:p>
+            <a:endParaRPr lang="ja-JP" altLang="en-US"/>
+          </a:p>
+        </p:txBody>
+      </p:sp>
+      <p:sp>
+        <p:nvSpPr>
+          <p:cNvPr id="47" name="図プレースホルダー 46">
+            <a:extLst>
+              <a:ext uri="{FF2B5EF4-FFF2-40B4-BE49-F238E27FC236}">
+                <a16:creationId xmlns:a16="http://schemas.microsoft.com/office/drawing/2014/main" id="{A74FEA05-972A-E76D-4881-7FE57BCEE0CC}"/>
+              </a:ext>
+            </a:extLst>
+          </p:cNvPr>
+          <p:cNvSpPr>
+            <a:spLocks noGrp="1"/>
+          </p:cNvSpPr>
+          <p:nvPr>
+            <p:ph type="pic" sz="quarter" idx="35"/>
+          </p:nvPr>
+        </p:nvSpPr>
+        <p:spPr/>
+        <p:txBody>
+          <a:bodyPr/>
+          <a:lstStyle/>
+          <a:p>
+            <a:endParaRPr lang="ja-JP" altLang="en-US"/>
+          </a:p>
+        </p:txBody>
+      </p:sp>
+      <p:sp>
+        <p:nvSpPr>
+          <p:cNvPr id="48" name="テキスト プレースホルダー 47">
+            <a:extLst>
+              <a:ext uri="{FF2B5EF4-FFF2-40B4-BE49-F238E27FC236}">
+                <a16:creationId xmlns:a16="http://schemas.microsoft.com/office/drawing/2014/main" id="{E9554C7E-85AD-A539-69C0-FC7CD04B9E5E}"/>
+              </a:ext>
+            </a:extLst>
+          </p:cNvPr>
+          <p:cNvSpPr>
+            <a:spLocks noGrp="1"/>
+          </p:cNvSpPr>
+          <p:nvPr>
+            <p:ph type="body" sz="quarter" idx="37"/>
+          </p:nvPr>
+        </p:nvSpPr>
+        <p:spPr/>
+        <p:txBody>
+          <a:bodyPr/>
+          <a:lstStyle/>
+          <a:p>
+            <a:endParaRPr kumimoji="1" lang="ja-JP" altLang="en-US" dirty="0"/>
+          </a:p>
+        </p:txBody>
+      </p:sp>
+      <p:sp>
+        <p:nvSpPr>
+          <p:cNvPr id="35" name="テキスト プレースホルダー 34">
+            <a:extLst>
+              <a:ext uri="{FF2B5EF4-FFF2-40B4-BE49-F238E27FC236}">
+                <a16:creationId xmlns:a16="http://schemas.microsoft.com/office/drawing/2014/main" id="{E0F96ECE-AD93-645B-18A5-C7BDB63B7560}"/>
+              </a:ext>
+            </a:extLst>
+          </p:cNvPr>
+          <p:cNvSpPr>
+            <a:spLocks noGrp="1"/>
+          </p:cNvSpPr>
+          <p:nvPr>
+            <p:ph type="body" sz="quarter" idx="12"/>
+          </p:nvPr>
+        </p:nvSpPr>
+        <p:spPr/>
+        <p:txBody>
+          <a:bodyPr/>
+          <a:lstStyle/>
+          <a:p>
+            <a:endParaRPr kumimoji="1" lang="ja-JP" altLang="en-US"/>
+          </a:p>
+        </p:txBody>
+      </p:sp>
+    </p:spTree>
+    <p:extLst>
+      <p:ext uri="{BB962C8B-B14F-4D97-AF65-F5344CB8AC3E}">
+        <p14:creationId xmlns:p14="http://schemas.microsoft.com/office/powerpoint/2010/main" val="2874494884"/>
+      </p:ext>
+    </p:extLst>
+  </p:cSld>
+  <p:clrMapOvr>
+    <a:masterClrMapping/>
+  </p:clrMapOvr>
+</p:sld>
+</file>
+
+<file path=ppt/slides/slide9.xml><?xml version="1.0" encoding="utf-8"?>
+<p:sld xmlns:a="http://schemas.openxmlformats.org/drawingml/2006/main" xmlns:r="http://schemas.openxmlformats.org/officeDocument/2006/relationships" xmlns:p="http://schemas.openxmlformats.org/presentationml/2006/main">
+  <p:cSld>
+    <p:spTree>
+      <p:nvGrpSpPr>
+        <p:cNvPr id="1" name=""/>
+        <p:cNvGrpSpPr/>
+        <p:nvPr/>
+      </p:nvGrpSpPr>
+      <p:grpSpPr>
+        <a:xfrm>
+          <a:off x="0" y="0"/>
+          <a:ext cx="0" cy="0"/>
+          <a:chOff x="0" y="0"/>
+          <a:chExt cx="0" cy="0"/>
+        </a:xfrm>
+      </p:grpSpPr>
+      <p:sp>
+        <p:nvSpPr>
+          <p:cNvPr id="2" name="タイトル 1">
+            <a:extLst>
+              <a:ext uri="{FF2B5EF4-FFF2-40B4-BE49-F238E27FC236}">
+                <a16:creationId xmlns:a16="http://schemas.microsoft.com/office/drawing/2014/main" id="{4900A63D-09C7-1169-3249-63901690E6EE}"/>
+              </a:ext>
+            </a:extLst>
+          </p:cNvPr>
+          <p:cNvSpPr>
+            <a:spLocks noGrp="1"/>
+          </p:cNvSpPr>
+          <p:nvPr>
+            <p:ph type="title"/>
+          </p:nvPr>
+        </p:nvSpPr>
+        <p:spPr/>
+        <p:txBody>
+          <a:bodyPr/>
+          <a:lstStyle/>
+          <a:p>
+            <a:r>
+              <a:rPr lang="ja-JP" altLang="en-US" dirty="0"/>
+              <a:t>１．事前準備</a:t>
+            </a:r>
+            <a:endParaRPr kumimoji="1" lang="ja-JP" altLang="en-US" dirty="0"/>
+          </a:p>
+        </p:txBody>
+      </p:sp>
+      <p:sp>
+        <p:nvSpPr>
+          <p:cNvPr id="4" name="フッター プレースホルダー 3">
+            <a:extLst>
+              <a:ext uri="{FF2B5EF4-FFF2-40B4-BE49-F238E27FC236}">
+                <a16:creationId xmlns:a16="http://schemas.microsoft.com/office/drawing/2014/main" id="{14AA4C4A-4C2A-1058-2861-E8DD0E245803}"/>
+              </a:ext>
+            </a:extLst>
+          </p:cNvPr>
+          <p:cNvSpPr>
+            <a:spLocks noGrp="1"/>
+          </p:cNvSpPr>
+          <p:nvPr>
+            <p:ph type="ftr" sz="quarter" idx="18"/>
+          </p:nvPr>
+        </p:nvSpPr>
+        <p:spPr/>
+        <p:txBody>
+          <a:bodyPr/>
+          <a:lstStyle/>
+          <a:p>
+            <a:r>
+              <a:rPr lang="en-US" altLang="ja-JP"/>
+              <a:t>Title / Month XX, 2020 (Please enter it from the "Insert" → "Header and Footer")</a:t>
+            </a:r>
+            <a:endParaRPr lang="en-US" dirty="0"/>
+          </a:p>
+        </p:txBody>
+      </p:sp>
+      <p:sp>
+        <p:nvSpPr>
+          <p:cNvPr id="5" name="スライド番号プレースホルダー 4">
+            <a:extLst>
+              <a:ext uri="{FF2B5EF4-FFF2-40B4-BE49-F238E27FC236}">
+                <a16:creationId xmlns:a16="http://schemas.microsoft.com/office/drawing/2014/main" id="{AE10086E-9116-7E0D-0369-D0084300CAE2}"/>
+              </a:ext>
+            </a:extLst>
+          </p:cNvPr>
+          <p:cNvSpPr>
+            <a:spLocks noGrp="1"/>
+          </p:cNvSpPr>
+          <p:nvPr>
+            <p:ph type="sldNum" sz="quarter" idx="19"/>
+          </p:nvPr>
+        </p:nvSpPr>
+        <p:spPr/>
+        <p:txBody>
+          <a:bodyPr/>
+          <a:lstStyle/>
+          <a:p>
+            <a:fld id="{A4345066-4952-40C1-BC8B-CE2851EC3EF2}" type="slidenum">
+              <a:rPr lang="ja-JP" altLang="en-US" smtClean="0">
+                <a:solidFill>
+                  <a:schemeClr val="bg1">
+                    <a:lumMod val="65000"/>
+                  </a:schemeClr>
+                </a:solidFill>
+              </a:rPr>
+              <a:pPr/>
+              <a:t>9</a:t>
+            </a:fld>
+            <a:endParaRPr lang="en-US" altLang="ja-JP" sz="1000" dirty="0">
+              <a:solidFill>
+                <a:schemeClr val="bg1">
+                  <a:lumMod val="65000"/>
+                </a:schemeClr>
+              </a:solidFill>
+            </a:endParaRPr>
+          </a:p>
+        </p:txBody>
+      </p:sp>
+      <p:sp>
+        <p:nvSpPr>
+          <p:cNvPr id="6" name="テキスト ボックス 5">
+            <a:extLst>
+              <a:ext uri="{FF2B5EF4-FFF2-40B4-BE49-F238E27FC236}">
+                <a16:creationId xmlns:a16="http://schemas.microsoft.com/office/drawing/2014/main" id="{42ECFE35-9D14-513C-36A5-4F647D8FD7A4}"/>
+              </a:ext>
+            </a:extLst>
+          </p:cNvPr>
+          <p:cNvSpPr txBox="1"/>
+          <p:nvPr/>
+        </p:nvSpPr>
+        <p:spPr>
+          <a:xfrm>
+            <a:off x="684213" y="808809"/>
+            <a:ext cx="6619120" cy="4801314"/>
+          </a:xfrm>
+          <a:prstGeom prst="rect">
+            <a:avLst/>
+          </a:prstGeom>
+          <a:noFill/>
+        </p:spPr>
+        <p:txBody>
+          <a:bodyPr wrap="none" rtlCol="0">
+            <a:spAutoFit/>
+          </a:bodyPr>
+          <a:lstStyle/>
+          <a:p>
+            <a:r>
+              <a:rPr kumimoji="1" lang="ja-JP" altLang="en-US" dirty="0"/>
+              <a:t>１．</a:t>
+            </a:r>
+            <a:r>
+              <a:rPr kumimoji="1" lang="en-US" altLang="ja-JP" dirty="0"/>
+              <a:t>Python</a:t>
+            </a:r>
+            <a:r>
+              <a:rPr kumimoji="1" lang="ja-JP" altLang="en-US" dirty="0"/>
+              <a:t>のインストール</a:t>
+            </a:r>
+            <a:endParaRPr kumimoji="1" lang="en-US" altLang="ja-JP" dirty="0"/>
+          </a:p>
+          <a:p>
+            <a:r>
+              <a:rPr lang="ja-JP" altLang="en-US" dirty="0"/>
+              <a:t>２．</a:t>
+            </a:r>
+            <a:r>
+              <a:rPr lang="en-US" altLang="ja-JP" dirty="0"/>
+              <a:t>Snowflake</a:t>
+            </a:r>
+            <a:r>
+              <a:rPr lang="ja-JP" altLang="en-US" dirty="0"/>
+              <a:t>関連モジュールのインポート</a:t>
+            </a:r>
+            <a:endParaRPr lang="en-US" altLang="ja-JP" dirty="0"/>
+          </a:p>
+          <a:p>
+            <a:endParaRPr lang="en-US" altLang="ja-JP" dirty="0"/>
+          </a:p>
+          <a:p>
+            <a:endParaRPr lang="en-US" altLang="ja-JP" dirty="0"/>
+          </a:p>
+          <a:p>
+            <a:endParaRPr lang="en-US" altLang="ja-JP" dirty="0"/>
+          </a:p>
+          <a:p>
+            <a:endParaRPr lang="en-US" altLang="ja-JP" dirty="0"/>
+          </a:p>
+          <a:p>
+            <a:r>
+              <a:rPr lang="ja-JP" altLang="en-US" dirty="0"/>
+              <a:t>３．接続情報の設定</a:t>
+            </a:r>
+            <a:endParaRPr lang="en-US" altLang="ja-JP" dirty="0"/>
+          </a:p>
+          <a:p>
+            <a:r>
+              <a:rPr lang="ja-JP" altLang="en-US" dirty="0"/>
+              <a:t>　ー１．</a:t>
+            </a:r>
+            <a:r>
+              <a:rPr lang="en-US" altLang="ja-JP" dirty="0"/>
+              <a:t>BDAP</a:t>
+            </a:r>
+            <a:r>
+              <a:rPr lang="ja-JP" altLang="en-US" dirty="0"/>
+              <a:t>利用申請を行う（</a:t>
+            </a:r>
+            <a:r>
+              <a:rPr lang="en-US" altLang="ja-JP" dirty="0">
+                <a:hlinkClick r:id="rId2"/>
+              </a:rPr>
+              <a:t>BDAP</a:t>
+            </a:r>
+            <a:r>
+              <a:rPr lang="ja-JP" altLang="en-US" dirty="0">
+                <a:hlinkClick r:id="rId2"/>
+              </a:rPr>
+              <a:t>利用申請システム</a:t>
+            </a:r>
+            <a:r>
+              <a:rPr lang="ja-JP" altLang="en-US" dirty="0"/>
+              <a:t>）</a:t>
+            </a:r>
+            <a:endParaRPr lang="en-US" altLang="ja-JP" dirty="0"/>
+          </a:p>
+          <a:p>
+            <a:r>
+              <a:rPr lang="ja-JP" altLang="en-US" dirty="0"/>
+              <a:t>　ー２．接続情報を記録する</a:t>
+            </a:r>
+            <a:endParaRPr lang="en-US" altLang="ja-JP" dirty="0"/>
+          </a:p>
+          <a:p>
+            <a:r>
+              <a:rPr lang="ja-JP" altLang="en-US" dirty="0"/>
+              <a:t>　ー３．</a:t>
+            </a:r>
+            <a:r>
+              <a:rPr lang="en-US" altLang="ja-JP" dirty="0" err="1"/>
+              <a:t>toml</a:t>
+            </a:r>
+            <a:r>
+              <a:rPr lang="ja-JP" altLang="en-US" dirty="0"/>
+              <a:t>ファイルを作成する　　（</a:t>
+            </a:r>
+            <a:r>
+              <a:rPr lang="en-US" altLang="ja-JP" dirty="0" err="1"/>
+              <a:t>private_key</a:t>
+            </a:r>
+            <a:r>
+              <a:rPr lang="ja-JP" altLang="en-US" dirty="0"/>
+              <a:t>情報は不要）　</a:t>
+            </a:r>
+            <a:endParaRPr lang="en-US" altLang="ja-JP" dirty="0"/>
+          </a:p>
+          <a:p>
+            <a:endParaRPr lang="en-US" altLang="ja-JP" dirty="0"/>
+          </a:p>
+          <a:p>
+            <a:r>
+              <a:rPr lang="ja-JP" altLang="en-US" dirty="0"/>
+              <a:t>４．</a:t>
+            </a:r>
+            <a:r>
+              <a:rPr lang="en-US" altLang="ja-JP" dirty="0"/>
+              <a:t>SQL</a:t>
+            </a:r>
+            <a:r>
+              <a:rPr lang="ja-JP" altLang="en-US" dirty="0"/>
+              <a:t>ファイルを準備</a:t>
+            </a:r>
+            <a:endParaRPr lang="en-US" altLang="ja-JP" dirty="0"/>
+          </a:p>
+          <a:p>
+            <a:endParaRPr lang="en-US" altLang="ja-JP" dirty="0"/>
+          </a:p>
+          <a:p>
+            <a:endParaRPr lang="en-US" altLang="ja-JP" dirty="0"/>
+          </a:p>
+          <a:p>
+            <a:endParaRPr lang="en-US" altLang="ja-JP" dirty="0"/>
+          </a:p>
+          <a:p>
+            <a:endParaRPr lang="en-US" altLang="ja-JP" dirty="0"/>
+          </a:p>
+          <a:p>
+            <a:r>
+              <a:rPr lang="ja-JP" altLang="en-US" dirty="0"/>
+              <a:t>　　　　その他</a:t>
+            </a:r>
+            <a:r>
+              <a:rPr lang="en-US" altLang="ja-JP" dirty="0"/>
+              <a:t>python</a:t>
+            </a:r>
+            <a:r>
+              <a:rPr lang="ja-JP" altLang="en-US" dirty="0"/>
+              <a:t>で使うモジュール　→</a:t>
+            </a:r>
+            <a:endParaRPr lang="en-US" altLang="ja-JP" dirty="0"/>
+          </a:p>
+        </p:txBody>
+      </p:sp>
+      <p:pic>
+        <p:nvPicPr>
+          <p:cNvPr id="8" name="図 7">
+            <a:extLst>
+              <a:ext uri="{FF2B5EF4-FFF2-40B4-BE49-F238E27FC236}">
+                <a16:creationId xmlns:a16="http://schemas.microsoft.com/office/drawing/2014/main" id="{6E9448F8-A8A9-5324-67A8-3046DC0329A4}"/>
+              </a:ext>
+            </a:extLst>
+          </p:cNvPr>
+          <p:cNvPicPr>
+            <a:picLocks noChangeAspect="1"/>
+          </p:cNvPicPr>
+          <p:nvPr/>
+        </p:nvPicPr>
+        <p:blipFill>
+          <a:blip r:embed="rId3"/>
+          <a:srcRect t="7501" b="7498"/>
+          <a:stretch>
+            <a:fillRect/>
+          </a:stretch>
+        </p:blipFill>
+        <p:spPr>
+          <a:xfrm>
+            <a:off x="1306648" y="1812476"/>
+            <a:ext cx="6820852" cy="161948"/>
+          </a:xfrm>
+          <a:prstGeom prst="rect">
+            <a:avLst/>
+          </a:prstGeom>
+        </p:spPr>
+      </p:pic>
+      <p:pic>
+        <p:nvPicPr>
+          <p:cNvPr id="12" name="図 11">
+            <a:extLst>
+              <a:ext uri="{FF2B5EF4-FFF2-40B4-BE49-F238E27FC236}">
+                <a16:creationId xmlns:a16="http://schemas.microsoft.com/office/drawing/2014/main" id="{69489F70-A899-C080-1F72-AFD8FDBF57DB}"/>
+              </a:ext>
+            </a:extLst>
+          </p:cNvPr>
+          <p:cNvPicPr>
+            <a:picLocks noChangeAspect="1"/>
+          </p:cNvPicPr>
+          <p:nvPr/>
+        </p:nvPicPr>
+        <p:blipFill>
+          <a:blip r:embed="rId4"/>
+          <a:srcRect l="415" r="1"/>
+          <a:stretch>
+            <a:fillRect/>
+          </a:stretch>
+        </p:blipFill>
+        <p:spPr>
+          <a:xfrm>
+            <a:off x="1306647" y="2061021"/>
+            <a:ext cx="6270777" cy="161948"/>
+          </a:xfrm>
+          <a:prstGeom prst="rect">
+            <a:avLst/>
+          </a:prstGeom>
+        </p:spPr>
+      </p:pic>
+      <p:pic>
+        <p:nvPicPr>
+          <p:cNvPr id="14" name="図 13">
+            <a:extLst>
+              <a:ext uri="{FF2B5EF4-FFF2-40B4-BE49-F238E27FC236}">
+                <a16:creationId xmlns:a16="http://schemas.microsoft.com/office/drawing/2014/main" id="{B67450D3-57D7-26D3-62A7-C684941B08DD}"/>
+              </a:ext>
+            </a:extLst>
+          </p:cNvPr>
+          <p:cNvPicPr>
+            <a:picLocks noChangeAspect="1"/>
+          </p:cNvPicPr>
+          <p:nvPr/>
+        </p:nvPicPr>
+        <p:blipFill>
+          <a:blip r:embed="rId5"/>
+          <a:srcRect l="1311" t="1" b="-1"/>
+          <a:stretch>
+            <a:fillRect/>
+          </a:stretch>
+        </p:blipFill>
+        <p:spPr>
+          <a:xfrm>
+            <a:off x="1306647" y="1573534"/>
+            <a:ext cx="6223782" cy="142895"/>
+          </a:xfrm>
+          <a:prstGeom prst="rect">
+            <a:avLst/>
+          </a:prstGeom>
+        </p:spPr>
+      </p:pic>
+      <p:sp>
+        <p:nvSpPr>
+          <p:cNvPr id="15" name="動作設定ボタン: 進む/次へ 14">
+            <a:hlinkClick r:id="rId6" action="ppaction://hlinksldjump" highlightClick="1"/>
+            <a:extLst>
+              <a:ext uri="{FF2B5EF4-FFF2-40B4-BE49-F238E27FC236}">
+                <a16:creationId xmlns:a16="http://schemas.microsoft.com/office/drawing/2014/main" id="{A0A457D4-AFDC-3210-2A8D-1E11F6B982D2}"/>
+              </a:ext>
+            </a:extLst>
+          </p:cNvPr>
+          <p:cNvSpPr/>
+          <p:nvPr/>
+        </p:nvSpPr>
+        <p:spPr>
+          <a:xfrm>
+            <a:off x="3573167" y="3075340"/>
+            <a:ext cx="288000" cy="216000"/>
+          </a:xfrm>
+          <a:prstGeom prst="actionButtonForwardNext">
+            <a:avLst/>
+          </a:prstGeom>
+          <a:solidFill>
+            <a:schemeClr val="bg2"/>
+          </a:solidFill>
+          <a:ln>
+            <a:noFill/>
+          </a:ln>
+        </p:spPr>
+        <p:style>
+          <a:lnRef idx="2">
+            <a:schemeClr val="accent1">
+              <a:shade val="50000"/>
+            </a:schemeClr>
+          </a:lnRef>
+          <a:fillRef idx="1">
+            <a:schemeClr val="accent1"/>
+          </a:fillRef>
+          <a:effectRef idx="0">
+            <a:schemeClr val="accent1"/>
+          </a:effectRef>
+          <a:fontRef idx="minor">
+            <a:schemeClr val="lt1"/>
+          </a:fontRef>
+        </p:style>
+        <p:txBody>
+          <a:bodyPr rtlCol="0" anchor="ctr"/>
+          <a:lstStyle/>
+          <a:p>
+            <a:pPr algn="ctr"/>
+            <a:endParaRPr kumimoji="1" lang="ja-JP" altLang="en-US"/>
+          </a:p>
+        </p:txBody>
+      </p:sp>
+      <p:sp>
+        <p:nvSpPr>
+          <p:cNvPr id="16" name="動作設定ボタン: 進む/次へ 15">
+            <a:hlinkClick r:id="rId7" action="ppaction://hlinksldjump" highlightClick="1"/>
+            <a:extLst>
+              <a:ext uri="{FF2B5EF4-FFF2-40B4-BE49-F238E27FC236}">
+                <a16:creationId xmlns:a16="http://schemas.microsoft.com/office/drawing/2014/main" id="{CF7938B4-FCE0-D850-2124-3A43354ECAFD}"/>
+              </a:ext>
+            </a:extLst>
+          </p:cNvPr>
+          <p:cNvSpPr/>
+          <p:nvPr/>
+        </p:nvSpPr>
+        <p:spPr>
+          <a:xfrm>
+            <a:off x="3782172" y="3369835"/>
+            <a:ext cx="288000" cy="216000"/>
+          </a:xfrm>
+          <a:prstGeom prst="actionButtonForwardNext">
+            <a:avLst/>
+          </a:prstGeom>
+          <a:solidFill>
+            <a:schemeClr val="bg2"/>
+          </a:solidFill>
+          <a:ln>
+            <a:noFill/>
+          </a:ln>
+        </p:spPr>
+        <p:style>
+          <a:lnRef idx="2">
+            <a:schemeClr val="accent1">
+              <a:shade val="50000"/>
+            </a:schemeClr>
+          </a:lnRef>
+          <a:fillRef idx="1">
+            <a:schemeClr val="accent1"/>
+          </a:fillRef>
+          <a:effectRef idx="0">
+            <a:schemeClr val="accent1"/>
+          </a:effectRef>
+          <a:fontRef idx="minor">
+            <a:schemeClr val="lt1"/>
+          </a:fontRef>
+        </p:style>
+        <p:txBody>
+          <a:bodyPr rtlCol="0" anchor="ctr"/>
+          <a:lstStyle/>
+          <a:p>
+            <a:pPr algn="ctr"/>
+            <a:endParaRPr kumimoji="1" lang="ja-JP" altLang="en-US"/>
+          </a:p>
+        </p:txBody>
+      </p:sp>
+      <p:pic>
+        <p:nvPicPr>
+          <p:cNvPr id="19" name="図 18">
+            <a:extLst>
+              <a:ext uri="{FF2B5EF4-FFF2-40B4-BE49-F238E27FC236}">
+                <a16:creationId xmlns:a16="http://schemas.microsoft.com/office/drawing/2014/main" id="{5602B46E-8BFA-4CCA-44BF-BDD09229080D}"/>
+              </a:ext>
+            </a:extLst>
+          </p:cNvPr>
+          <p:cNvPicPr>
+            <a:picLocks noChangeAspect="1"/>
+          </p:cNvPicPr>
+          <p:nvPr/>
+        </p:nvPicPr>
+        <p:blipFill>
+          <a:blip r:embed="rId8"/>
+          <a:stretch>
+            <a:fillRect/>
+          </a:stretch>
+        </p:blipFill>
+        <p:spPr>
+          <a:xfrm>
+            <a:off x="1248892" y="4244873"/>
+            <a:ext cx="3323108" cy="809105"/>
+          </a:xfrm>
+          <a:prstGeom prst="rect">
+            <a:avLst/>
+          </a:prstGeom>
+        </p:spPr>
+      </p:pic>
+      <p:graphicFrame>
+        <p:nvGraphicFramePr>
+          <p:cNvPr id="20" name="表 19">
+            <a:extLst>
+              <a:ext uri="{FF2B5EF4-FFF2-40B4-BE49-F238E27FC236}">
+                <a16:creationId xmlns:a16="http://schemas.microsoft.com/office/drawing/2014/main" id="{F31DE33C-6B33-CDF0-03C8-888177E283D7}"/>
+              </a:ext>
+            </a:extLst>
+          </p:cNvPr>
+          <p:cNvGraphicFramePr>
+            <a:graphicFrameLocks noGrp="1"/>
+          </p:cNvGraphicFramePr>
+          <p:nvPr>
+            <p:extLst>
+              <p:ext uri="{D42A27DB-BD31-4B8C-83A1-F6EECF244321}">
+                <p14:modId xmlns:p14="http://schemas.microsoft.com/office/powerpoint/2010/main" val="1955140160"/>
+              </p:ext>
+            </p:extLst>
+          </p:nvPr>
+        </p:nvGraphicFramePr>
+        <p:xfrm>
+          <a:off x="4994675" y="4186274"/>
+          <a:ext cx="3465113" cy="1463040"/>
+        </p:xfrm>
+        <a:graphic>
+          <a:graphicData uri="http://schemas.openxmlformats.org/drawingml/2006/table">
+            <a:tbl>
+              <a:tblPr firstRow="1" bandRow="1">
+                <a:tableStyleId>{5C22544A-7EE6-4342-B048-85BDC9FD1C3A}</a:tableStyleId>
+              </a:tblPr>
+              <a:tblGrid>
+                <a:gridCol w="999187">
+                  <a:extLst>
+                    <a:ext uri="{9D8B030D-6E8A-4147-A177-3AD203B41FA5}">
+                      <a16:colId xmlns:a16="http://schemas.microsoft.com/office/drawing/2014/main" val="146844778"/>
+                    </a:ext>
+                  </a:extLst>
+                </a:gridCol>
+                <a:gridCol w="2465926">
+                  <a:extLst>
+                    <a:ext uri="{9D8B030D-6E8A-4147-A177-3AD203B41FA5}">
+                      <a16:colId xmlns:a16="http://schemas.microsoft.com/office/drawing/2014/main" val="3806578550"/>
+                    </a:ext>
+                  </a:extLst>
+                </a:gridCol>
+              </a:tblGrid>
+              <a:tr h="0">
+                <a:tc>
+                  <a:txBody>
+                    <a:bodyPr/>
+                    <a:lstStyle/>
+                    <a:p>
+                      <a:r>
+                        <a:rPr kumimoji="1" lang="ja-JP" altLang="en-US" sz="1000" dirty="0"/>
+                        <a:t>モジュール名</a:t>
+                      </a:r>
+                    </a:p>
+                  </a:txBody>
+                  <a:tcPr/>
+                </a:tc>
+                <a:tc>
+                  <a:txBody>
+                    <a:bodyPr/>
+                    <a:lstStyle/>
+                    <a:p>
+                      <a:r>
+                        <a:rPr kumimoji="1" lang="ja-JP" altLang="en-US" sz="1000" dirty="0"/>
+                        <a:t>用途</a:t>
+                      </a:r>
+                    </a:p>
+                  </a:txBody>
+                  <a:tcPr/>
+                </a:tc>
+                <a:extLst>
+                  <a:ext uri="{0D108BD9-81ED-4DB2-BD59-A6C34878D82A}">
+                    <a16:rowId xmlns:a16="http://schemas.microsoft.com/office/drawing/2014/main" val="1203403393"/>
+                  </a:ext>
+                </a:extLst>
+              </a:tr>
+              <a:tr h="0">
+                <a:tc>
+                  <a:txBody>
+                    <a:bodyPr/>
+                    <a:lstStyle/>
+                    <a:p>
+                      <a:r>
+                        <a:rPr kumimoji="1" lang="en-US" altLang="ja-JP" sz="1000" dirty="0" err="1"/>
+                        <a:t>tempfile</a:t>
+                      </a:r>
+                      <a:endParaRPr kumimoji="1" lang="en-US" altLang="ja-JP" sz="1000" dirty="0"/>
+                    </a:p>
+                  </a:txBody>
+                  <a:tcPr/>
+                </a:tc>
+                <a:tc>
+                  <a:txBody>
+                    <a:bodyPr/>
+                    <a:lstStyle/>
+                    <a:p>
+                      <a:r>
+                        <a:rPr kumimoji="1" lang="ja-JP" altLang="en-US" sz="1000" dirty="0"/>
+                        <a:t>一時ファイル・ディレクトリ作成</a:t>
+                      </a:r>
+                    </a:p>
+                  </a:txBody>
+                  <a:tcPr/>
+                </a:tc>
+                <a:extLst>
+                  <a:ext uri="{0D108BD9-81ED-4DB2-BD59-A6C34878D82A}">
+                    <a16:rowId xmlns:a16="http://schemas.microsoft.com/office/drawing/2014/main" val="3035347182"/>
+                  </a:ext>
+                </a:extLst>
+              </a:tr>
+              <a:tr h="0">
+                <a:tc>
+                  <a:txBody>
+                    <a:bodyPr/>
+                    <a:lstStyle/>
+                    <a:p>
+                      <a:r>
+                        <a:rPr kumimoji="1" lang="en-US" altLang="ja-JP" sz="1000" dirty="0" err="1"/>
+                        <a:t>psutil</a:t>
+                      </a:r>
+                      <a:endParaRPr kumimoji="1" lang="ja-JP" altLang="en-US" sz="1000" dirty="0"/>
+                    </a:p>
+                  </a:txBody>
+                  <a:tcPr/>
+                </a:tc>
+                <a:tc>
+                  <a:txBody>
+                    <a:bodyPr/>
+                    <a:lstStyle/>
+                    <a:p>
+                      <a:r>
+                        <a:rPr kumimoji="1" lang="ja-JP" altLang="en-US" sz="1000" dirty="0"/>
+                        <a:t>プロセス・メモリ・</a:t>
+                      </a:r>
+                      <a:r>
+                        <a:rPr kumimoji="1" lang="en-US" altLang="ja-JP" sz="1000" dirty="0"/>
+                        <a:t>CPU</a:t>
+                      </a:r>
+                      <a:r>
+                        <a:rPr kumimoji="1" lang="ja-JP" altLang="en-US" sz="1000" dirty="0"/>
+                        <a:t>などシステム情報取得</a:t>
+                      </a:r>
+                    </a:p>
+                  </a:txBody>
+                  <a:tcPr/>
+                </a:tc>
+                <a:extLst>
+                  <a:ext uri="{0D108BD9-81ED-4DB2-BD59-A6C34878D82A}">
+                    <a16:rowId xmlns:a16="http://schemas.microsoft.com/office/drawing/2014/main" val="1169986510"/>
+                  </a:ext>
+                </a:extLst>
+              </a:tr>
+              <a:tr h="0">
+                <a:tc>
+                  <a:txBody>
+                    <a:bodyPr/>
+                    <a:lstStyle/>
+                    <a:p>
+                      <a:r>
+                        <a:rPr kumimoji="1" lang="en-US" altLang="ja-JP" sz="1000" dirty="0" err="1"/>
+                        <a:t>json</a:t>
+                      </a:r>
+                      <a:endParaRPr kumimoji="1" lang="ja-JP" altLang="en-US" sz="1000" dirty="0"/>
+                    </a:p>
+                  </a:txBody>
+                  <a:tcPr/>
+                </a:tc>
+                <a:tc>
+                  <a:txBody>
+                    <a:bodyPr/>
+                    <a:lstStyle/>
+                    <a:p>
+                      <a:r>
+                        <a:rPr kumimoji="1" lang="en-US" altLang="ja-JP" sz="1000" dirty="0"/>
+                        <a:t>Json</a:t>
+                      </a:r>
+                      <a:r>
+                        <a:rPr kumimoji="1" lang="ja-JP" altLang="en-US" sz="1000" dirty="0"/>
+                        <a:t>ファイルの読み書き</a:t>
+                      </a:r>
+                    </a:p>
+                  </a:txBody>
+                  <a:tcPr/>
+                </a:tc>
+                <a:extLst>
+                  <a:ext uri="{0D108BD9-81ED-4DB2-BD59-A6C34878D82A}">
+                    <a16:rowId xmlns:a16="http://schemas.microsoft.com/office/drawing/2014/main" val="3047355892"/>
+                  </a:ext>
+                </a:extLst>
+              </a:tr>
+              <a:tr h="0">
+                <a:tc>
+                  <a:txBody>
+                    <a:bodyPr/>
+                    <a:lstStyle/>
+                    <a:p>
+                      <a:r>
+                        <a:rPr kumimoji="1" lang="en-US" altLang="ja-JP" sz="1000" dirty="0" err="1"/>
+                        <a:t>shutil</a:t>
+                      </a:r>
+                      <a:endParaRPr kumimoji="1" lang="ja-JP" altLang="en-US" sz="1000" dirty="0"/>
+                    </a:p>
+                  </a:txBody>
+                  <a:tcPr/>
+                </a:tc>
+                <a:tc>
+                  <a:txBody>
+                    <a:bodyPr/>
+                    <a:lstStyle/>
+                    <a:p>
+                      <a:r>
+                        <a:rPr kumimoji="1" lang="ja-JP" altLang="en-US" sz="1000" dirty="0"/>
+                        <a:t>高水準のファイル操作</a:t>
+                      </a:r>
+                    </a:p>
+                  </a:txBody>
+                  <a:tcPr/>
+                </a:tc>
+                <a:extLst>
+                  <a:ext uri="{0D108BD9-81ED-4DB2-BD59-A6C34878D82A}">
+                    <a16:rowId xmlns:a16="http://schemas.microsoft.com/office/drawing/2014/main" val="3846729528"/>
+                  </a:ext>
+                </a:extLst>
+              </a:tr>
+              <a:tr h="0">
+                <a:tc>
+                  <a:txBody>
+                    <a:bodyPr/>
+                    <a:lstStyle/>
+                    <a:p>
+                      <a:r>
+                        <a:rPr kumimoji="1" lang="en-US" altLang="ja-JP" sz="1000" dirty="0" err="1"/>
+                        <a:t>pathlib</a:t>
+                      </a:r>
+                      <a:endParaRPr kumimoji="1" lang="ja-JP" altLang="en-US" sz="1000" dirty="0"/>
+                    </a:p>
+                  </a:txBody>
+                  <a:tcPr/>
+                </a:tc>
+                <a:tc>
+                  <a:txBody>
+                    <a:bodyPr/>
+                    <a:lstStyle/>
+                    <a:p>
+                      <a:r>
+                        <a:rPr kumimoji="1" lang="ja-JP" altLang="en-US" sz="1000" dirty="0"/>
+                        <a:t>安全なファイル操作</a:t>
+                      </a:r>
+                    </a:p>
+                  </a:txBody>
+                  <a:tcPr/>
+                </a:tc>
+                <a:extLst>
+                  <a:ext uri="{0D108BD9-81ED-4DB2-BD59-A6C34878D82A}">
+                    <a16:rowId xmlns:a16="http://schemas.microsoft.com/office/drawing/2014/main" val="2526141651"/>
+                  </a:ext>
+                </a:extLst>
+              </a:tr>
+            </a:tbl>
+          </a:graphicData>
+        </a:graphic>
+      </p:graphicFrame>
+      <p:sp>
+        <p:nvSpPr>
+          <p:cNvPr id="22" name="テキスト ボックス 21">
+            <a:extLst>
+              <a:ext uri="{FF2B5EF4-FFF2-40B4-BE49-F238E27FC236}">
+                <a16:creationId xmlns:a16="http://schemas.microsoft.com/office/drawing/2014/main" id="{C7C040AF-79E2-58F2-F109-DF633A2D3345}"/>
+              </a:ext>
+            </a:extLst>
+          </p:cNvPr>
+          <p:cNvSpPr txBox="1"/>
+          <p:nvPr/>
+        </p:nvSpPr>
+        <p:spPr>
+          <a:xfrm>
+            <a:off x="4994675" y="3925144"/>
+            <a:ext cx="1479892" cy="276999"/>
+          </a:xfrm>
+          <a:prstGeom prst="rect">
+            <a:avLst/>
+          </a:prstGeom>
+          <a:noFill/>
+        </p:spPr>
+        <p:txBody>
+          <a:bodyPr wrap="none" rtlCol="0">
+            <a:spAutoFit/>
+          </a:bodyPr>
+          <a:lstStyle/>
+          <a:p>
+            <a:r>
+              <a:rPr lang="ja-JP" altLang="en-US" sz="1200" dirty="0"/>
+              <a:t>専用</a:t>
+            </a:r>
+            <a:r>
+              <a:rPr lang="en-US" altLang="ja-JP" sz="1200" dirty="0" err="1"/>
+              <a:t>WareHouse</a:t>
+            </a:r>
+            <a:r>
+              <a:rPr lang="en-US" altLang="ja-JP" sz="1200" dirty="0"/>
+              <a:t>+α</a:t>
+            </a:r>
+            <a:endParaRPr kumimoji="1" lang="ja-JP" altLang="en-US" sz="1200" dirty="0"/>
+          </a:p>
+        </p:txBody>
+      </p:sp>
+    </p:spTree>
+    <p:extLst>
+      <p:ext uri="{BB962C8B-B14F-4D97-AF65-F5344CB8AC3E}">
+        <p14:creationId xmlns:p14="http://schemas.microsoft.com/office/powerpoint/2010/main" val="2479610975"/>
       </p:ext>
     </p:extLst>
   </p:cSld>

</xml_diff>